<commit_message>
feat: riktig sliderekkefølge - Oppgave 1, 2, 3
</commit_message>
<xml_diff>
--- a/presentasjon/ITK2004-Eksamen-2026.pptx
+++ b/presentasjon/ITK2004-Eksamen-2026.pptx
@@ -2154,7 +2154,7 @@
                 <a:ea typeface="Calibri" pitchFamily="34" charset="-122"/>
                 <a:cs typeface="Calibri" pitchFamily="34" charset="-120"/>
               </a:rPr>
-              <a:t>Nettverk · Web · Active Directory</a:t>
+              <a:t>Web · Nettverk · Active Directory</a:t>
             </a:r>
             <a:endParaRPr lang="en-US" sz="2000" dirty="0"/>
           </a:p>
@@ -6153,46 +6153,352 @@
                 <a:ea typeface="Calibri" pitchFamily="34" charset="-122"/>
                 <a:cs typeface="Calibri" pitchFamily="34" charset="-120"/>
               </a:rPr>
-              <a:t>Oppgave 2 — Drift: Nettverkstopologi</a:t>
+              <a:t>Oppgave 1 — Utvikling: Arkitektur</a:t>
             </a:r>
             <a:endParaRPr lang="en-US" sz="2800" dirty="0"/>
           </a:p>
         </p:txBody>
       </p:sp>
-      <p:pic>
-        <p:nvPicPr>
-          <p:cNvPr id="4" name="Image 0" descr="C:\Eksamen_2026\bilder\alle_ip_config_ferdig.png">    </p:cNvPr>
-          <p:cNvPicPr>
-            <a:picLocks noChangeAspect="1"/>
-          </p:cNvPicPr>
-          <p:nvPr/>
-        </p:nvPicPr>
-        <p:blipFill>
-          <a:blip r:embed="rId1"/>
-          <a:stretch>
-            <a:fillRect/>
-          </a:stretch>
-        </p:blipFill>
-        <p:spPr>
-          <a:xfrm>
-            <a:off x="457200" y="1005840"/>
-            <a:ext cx="4754880" cy="3474720"/>
-          </a:xfrm>
-          <a:prstGeom prst="rect">
-            <a:avLst/>
-          </a:prstGeom>
-        </p:spPr>
-      </p:pic>
-      <p:sp>
-        <p:nvSpPr>
-          <p:cNvPr id="5" name="Text 2"/>
-          <p:cNvSpPr/>
-          <p:nvPr/>
-        </p:nvSpPr>
-        <p:spPr>
-          <a:xfrm>
-            <a:off x="5394960" y="1188720"/>
-            <a:ext cx="3474720" cy="2286000"/>
+      <p:sp>
+        <p:nvSpPr>
+          <p:cNvPr id="4" name="Shape 2"/>
+          <p:cNvSpPr/>
+          <p:nvPr/>
+        </p:nvSpPr>
+        <p:spPr>
+          <a:xfrm>
+            <a:off x="1371600" y="1097280"/>
+            <a:ext cx="6400800" cy="777240"/>
+          </a:xfrm>
+          <a:prstGeom prst="rect">
+            <a:avLst/>
+          </a:prstGeom>
+          <a:solidFill>
+            <a:srgbClr val="1C7293"/>
+          </a:solidFill>
+          <a:ln w="12700">
+            <a:solidFill>
+              <a:srgbClr val="1C7293"/>
+            </a:solidFill>
+            <a:prstDash val="solid"/>
+          </a:ln>
+          <a:effectLst>
+            <a:outerShdw sx="100000" sy="100000" kx="0" ky="0" algn="bl" rotWithShape="0" blurRad="101600" dist="38100" dir="8100000">
+              <a:srgbClr val="000000">
+                <a:alpha val="15000"/>
+              </a:srgbClr>
+            </a:outerShdw>
+          </a:effectLst>
+        </p:spPr>
+      </p:sp>
+      <p:sp>
+        <p:nvSpPr>
+          <p:cNvPr id="5" name="Text 3"/>
+          <p:cNvSpPr/>
+          <p:nvPr/>
+        </p:nvSpPr>
+        <p:spPr>
+          <a:xfrm>
+            <a:off x="1371600" y="1097280"/>
+            <a:ext cx="3200400" cy="777240"/>
+          </a:xfrm>
+          <a:prstGeom prst="rect">
+            <a:avLst/>
+          </a:prstGeom>
+          <a:noFill/>
+          <a:ln/>
+        </p:spPr>
+        <p:txBody>
+          <a:bodyPr wrap="square" lIns="0" tIns="0" rIns="0" bIns="0" rtlCol="0" anchor="ctr"/>
+          <a:lstStyle/>
+          <a:p>
+            <a:pPr algn="ctr" indent="0" marL="0">
+              <a:buNone/>
+            </a:pPr>
+            <a:r>
+              <a:rPr lang="en-US" sz="1800" b="1" dirty="0">
+                <a:solidFill>
+                  <a:srgbClr val="FFFFFF"/>
+                </a:solidFill>
+                <a:latin typeface="Calibri" pitchFamily="34" charset="0"/>
+                <a:ea typeface="Calibri" pitchFamily="34" charset="-122"/>
+                <a:cs typeface="Calibri" pitchFamily="34" charset="-120"/>
+              </a:rPr>
+              <a:t>Nettleser</a:t>
+            </a:r>
+            <a:endParaRPr lang="en-US" sz="1800" dirty="0"/>
+          </a:p>
+        </p:txBody>
+      </p:sp>
+      <p:sp>
+        <p:nvSpPr>
+          <p:cNvPr id="6" name="Text 4"/>
+          <p:cNvSpPr/>
+          <p:nvPr/>
+        </p:nvSpPr>
+        <p:spPr>
+          <a:xfrm>
+            <a:off x="4572000" y="1097280"/>
+            <a:ext cx="3200400" cy="777240"/>
+          </a:xfrm>
+          <a:prstGeom prst="rect">
+            <a:avLst/>
+          </a:prstGeom>
+          <a:noFill/>
+          <a:ln/>
+        </p:spPr>
+        <p:txBody>
+          <a:bodyPr wrap="square" lIns="0" tIns="0" rIns="0" bIns="0" rtlCol="0" anchor="ctr"/>
+          <a:lstStyle/>
+          <a:p>
+            <a:pPr algn="ctr" indent="0" marL="0">
+              <a:buNone/>
+            </a:pPr>
+            <a:r>
+              <a:rPr lang="en-US" sz="1400" dirty="0">
+                <a:solidFill>
+                  <a:srgbClr val="A8D4F5"/>
+                </a:solidFill>
+                <a:latin typeface="Calibri" pitchFamily="34" charset="0"/>
+                <a:ea typeface="Calibri" pitchFamily="34" charset="-122"/>
+                <a:cs typeface="Calibri" pitchFamily="34" charset="-120"/>
+              </a:rPr>
+              <a:t>HTML + CSS (plain)</a:t>
+            </a:r>
+            <a:endParaRPr lang="en-US" sz="1400" dirty="0"/>
+          </a:p>
+        </p:txBody>
+      </p:sp>
+      <p:sp>
+        <p:nvSpPr>
+          <p:cNvPr id="7" name="Shape 5"/>
+          <p:cNvSpPr/>
+          <p:nvPr/>
+        </p:nvSpPr>
+        <p:spPr>
+          <a:xfrm>
+            <a:off x="1371600" y="2103120"/>
+            <a:ext cx="6400800" cy="777240"/>
+          </a:xfrm>
+          <a:prstGeom prst="rect">
+            <a:avLst/>
+          </a:prstGeom>
+          <a:solidFill>
+            <a:srgbClr val="065A82"/>
+          </a:solidFill>
+          <a:ln w="12700">
+            <a:solidFill>
+              <a:srgbClr val="065A82"/>
+            </a:solidFill>
+            <a:prstDash val="solid"/>
+          </a:ln>
+          <a:effectLst>
+            <a:outerShdw sx="100000" sy="100000" kx="0" ky="0" algn="bl" rotWithShape="0" blurRad="101600" dist="38100" dir="8100000">
+              <a:srgbClr val="000000">
+                <a:alpha val="15000"/>
+              </a:srgbClr>
+            </a:outerShdw>
+          </a:effectLst>
+        </p:spPr>
+      </p:sp>
+      <p:sp>
+        <p:nvSpPr>
+          <p:cNvPr id="8" name="Text 6"/>
+          <p:cNvSpPr/>
+          <p:nvPr/>
+        </p:nvSpPr>
+        <p:spPr>
+          <a:xfrm>
+            <a:off x="1371600" y="2103120"/>
+            <a:ext cx="3200400" cy="777240"/>
+          </a:xfrm>
+          <a:prstGeom prst="rect">
+            <a:avLst/>
+          </a:prstGeom>
+          <a:noFill/>
+          <a:ln/>
+        </p:spPr>
+        <p:txBody>
+          <a:bodyPr wrap="square" lIns="0" tIns="0" rIns="0" bIns="0" rtlCol="0" anchor="ctr"/>
+          <a:lstStyle/>
+          <a:p>
+            <a:pPr algn="ctr" indent="0" marL="0">
+              <a:buNone/>
+            </a:pPr>
+            <a:r>
+              <a:rPr lang="en-US" sz="1800" b="1" dirty="0">
+                <a:solidFill>
+                  <a:srgbClr val="FFFFFF"/>
+                </a:solidFill>
+                <a:latin typeface="Calibri" pitchFamily="34" charset="0"/>
+                <a:ea typeface="Calibri" pitchFamily="34" charset="-122"/>
+                <a:cs typeface="Calibri" pitchFamily="34" charset="-120"/>
+              </a:rPr>
+              <a:t>Backend</a:t>
+            </a:r>
+            <a:endParaRPr lang="en-US" sz="1800" dirty="0"/>
+          </a:p>
+        </p:txBody>
+      </p:sp>
+      <p:sp>
+        <p:nvSpPr>
+          <p:cNvPr id="9" name="Text 7"/>
+          <p:cNvSpPr/>
+          <p:nvPr/>
+        </p:nvSpPr>
+        <p:spPr>
+          <a:xfrm>
+            <a:off x="4572000" y="2103120"/>
+            <a:ext cx="3200400" cy="777240"/>
+          </a:xfrm>
+          <a:prstGeom prst="rect">
+            <a:avLst/>
+          </a:prstGeom>
+          <a:noFill/>
+          <a:ln/>
+        </p:spPr>
+        <p:txBody>
+          <a:bodyPr wrap="square" lIns="0" tIns="0" rIns="0" bIns="0" rtlCol="0" anchor="ctr"/>
+          <a:lstStyle/>
+          <a:p>
+            <a:pPr algn="ctr" indent="0" marL="0">
+              <a:buNone/>
+            </a:pPr>
+            <a:r>
+              <a:rPr lang="en-US" sz="1400" dirty="0">
+                <a:solidFill>
+                  <a:srgbClr val="A8D4F5"/>
+                </a:solidFill>
+                <a:latin typeface="Calibri" pitchFamily="34" charset="0"/>
+                <a:ea typeface="Calibri" pitchFamily="34" charset="-122"/>
+                <a:cs typeface="Calibri" pitchFamily="34" charset="-120"/>
+              </a:rPr>
+              <a:t>Node.js + Express</a:t>
+            </a:r>
+            <a:endParaRPr lang="en-US" sz="1400" dirty="0"/>
+          </a:p>
+        </p:txBody>
+      </p:sp>
+      <p:sp>
+        <p:nvSpPr>
+          <p:cNvPr id="10" name="Shape 8"/>
+          <p:cNvSpPr/>
+          <p:nvPr/>
+        </p:nvSpPr>
+        <p:spPr>
+          <a:xfrm>
+            <a:off x="1371600" y="3108960"/>
+            <a:ext cx="6400800" cy="777240"/>
+          </a:xfrm>
+          <a:prstGeom prst="rect">
+            <a:avLst/>
+          </a:prstGeom>
+          <a:solidFill>
+            <a:srgbClr val="21295C"/>
+          </a:solidFill>
+          <a:ln w="12700">
+            <a:solidFill>
+              <a:srgbClr val="21295C"/>
+            </a:solidFill>
+            <a:prstDash val="solid"/>
+          </a:ln>
+          <a:effectLst>
+            <a:outerShdw sx="100000" sy="100000" kx="0" ky="0" algn="bl" rotWithShape="0" blurRad="101600" dist="38100" dir="8100000">
+              <a:srgbClr val="000000">
+                <a:alpha val="15000"/>
+              </a:srgbClr>
+            </a:outerShdw>
+          </a:effectLst>
+        </p:spPr>
+      </p:sp>
+      <p:sp>
+        <p:nvSpPr>
+          <p:cNvPr id="11" name="Text 9"/>
+          <p:cNvSpPr/>
+          <p:nvPr/>
+        </p:nvSpPr>
+        <p:spPr>
+          <a:xfrm>
+            <a:off x="1371600" y="3108960"/>
+            <a:ext cx="3200400" cy="777240"/>
+          </a:xfrm>
+          <a:prstGeom prst="rect">
+            <a:avLst/>
+          </a:prstGeom>
+          <a:noFill/>
+          <a:ln/>
+        </p:spPr>
+        <p:txBody>
+          <a:bodyPr wrap="square" lIns="0" tIns="0" rIns="0" bIns="0" rtlCol="0" anchor="ctr"/>
+          <a:lstStyle/>
+          <a:p>
+            <a:pPr algn="ctr" indent="0" marL="0">
+              <a:buNone/>
+            </a:pPr>
+            <a:r>
+              <a:rPr lang="en-US" sz="1800" b="1" dirty="0">
+                <a:solidFill>
+                  <a:srgbClr val="FFFFFF"/>
+                </a:solidFill>
+                <a:latin typeface="Calibri" pitchFamily="34" charset="0"/>
+                <a:ea typeface="Calibri" pitchFamily="34" charset="-122"/>
+                <a:cs typeface="Calibri" pitchFamily="34" charset="-120"/>
+              </a:rPr>
+              <a:t>Database</a:t>
+            </a:r>
+            <a:endParaRPr lang="en-US" sz="1800" dirty="0"/>
+          </a:p>
+        </p:txBody>
+      </p:sp>
+      <p:sp>
+        <p:nvSpPr>
+          <p:cNvPr id="12" name="Text 10"/>
+          <p:cNvSpPr/>
+          <p:nvPr/>
+        </p:nvSpPr>
+        <p:spPr>
+          <a:xfrm>
+            <a:off x="4572000" y="3108960"/>
+            <a:ext cx="3200400" cy="777240"/>
+          </a:xfrm>
+          <a:prstGeom prst="rect">
+            <a:avLst/>
+          </a:prstGeom>
+          <a:noFill/>
+          <a:ln/>
+        </p:spPr>
+        <p:txBody>
+          <a:bodyPr wrap="square" lIns="0" tIns="0" rIns="0" bIns="0" rtlCol="0" anchor="ctr"/>
+          <a:lstStyle/>
+          <a:p>
+            <a:pPr algn="ctr" indent="0" marL="0">
+              <a:buNone/>
+            </a:pPr>
+            <a:r>
+              <a:rPr lang="en-US" sz="1400" dirty="0">
+                <a:solidFill>
+                  <a:srgbClr val="A8D4F5"/>
+                </a:solidFill>
+                <a:latin typeface="Calibri" pitchFamily="34" charset="0"/>
+                <a:ea typeface="Calibri" pitchFamily="34" charset="-122"/>
+                <a:cs typeface="Calibri" pitchFamily="34" charset="-120"/>
+              </a:rPr>
+              <a:t>MariaDB i Docker</a:t>
+            </a:r>
+            <a:endParaRPr lang="en-US" sz="1400" dirty="0"/>
+          </a:p>
+        </p:txBody>
+      </p:sp>
+      <p:sp>
+        <p:nvSpPr>
+          <p:cNvPr id="13" name="Text 11"/>
+          <p:cNvSpPr/>
+          <p:nvPr/>
+        </p:nvSpPr>
+        <p:spPr>
+          <a:xfrm>
+            <a:off x="457200" y="4160520"/>
+            <a:ext cx="8229600" cy="777240"/>
           </a:xfrm>
           <a:prstGeom prst="rect">
             <a:avLst/>
@@ -6211,13 +6517,13 @@
             <a:r>
               <a:rPr lang="en-US" sz="1300" dirty="0">
                 <a:solidFill>
-                  <a:srgbClr val="1E293B"/>
-                </a:solidFill>
-                <a:latin typeface="Calibri" pitchFamily="34" charset="0"/>
-                <a:ea typeface="Calibri" pitchFamily="34" charset="-122"/>
-                <a:cs typeface="Calibri" pitchFamily="34" charset="-120"/>
-              </a:rPr>
-              <a:t>1 switch (Cisco 2960), 1 router (Cisco 2911)</a:t>
+                  <a:srgbClr val="64748B"/>
+                </a:solidFill>
+                <a:latin typeface="Calibri" pitchFamily="34" charset="0"/>
+                <a:ea typeface="Calibri" pitchFamily="34" charset="-122"/>
+                <a:cs typeface="Calibri" pitchFamily="34" charset="-120"/>
+              </a:rPr>
+              <a:t>docker compose up --build — én kommando</a:t>
             </a:r>
             <a:endParaRPr lang="en-US" sz="1300" dirty="0"/>
           </a:p>
@@ -6229,13 +6535,13 @@
             <a:r>
               <a:rPr lang="en-US" sz="1300" dirty="0">
                 <a:solidFill>
-                  <a:srgbClr val="1E293B"/>
-                </a:solidFill>
-                <a:latin typeface="Calibri" pitchFamily="34" charset="0"/>
-                <a:ea typeface="Calibri" pitchFamily="34" charset="-122"/>
-                <a:cs typeface="Calibri" pitchFamily="34" charset="-120"/>
-              </a:rPr>
-              <a:t>3 bedrifter × (2 PC + 1 printer)</a:t>
+                  <a:srgbClr val="64748B"/>
+                </a:solidFill>
+                <a:latin typeface="Calibri" pitchFamily="34" charset="0"/>
+                <a:ea typeface="Calibri" pitchFamily="34" charset="-122"/>
+                <a:cs typeface="Calibri" pitchFamily="34" charset="-120"/>
+              </a:rPr>
+              <a:t>Session-basert auth med bcrypt</a:t>
             </a:r>
             <a:endParaRPr lang="en-US" sz="1300" dirty="0"/>
           </a:p>
@@ -6247,13 +6553,13 @@
             <a:r>
               <a:rPr lang="en-US" sz="1300" dirty="0">
                 <a:solidFill>
-                  <a:srgbClr val="1E293B"/>
-                </a:solidFill>
-                <a:latin typeface="Calibri" pitchFamily="34" charset="0"/>
-                <a:ea typeface="Calibri" pitchFamily="34" charset="-122"/>
-                <a:cs typeface="Calibri" pitchFamily="34" charset="-120"/>
-              </a:rPr>
-              <a:t>Server i VLAN 99</a:t>
+                  <a:srgbClr val="64748B"/>
+                </a:solidFill>
+                <a:latin typeface="Calibri" pitchFamily="34" charset="0"/>
+                <a:ea typeface="Calibri" pitchFamily="34" charset="-122"/>
+                <a:cs typeface="Calibri" pitchFamily="34" charset="-120"/>
+              </a:rPr>
+              <a:t>Hver bedrift ser kun egne data</a:t>
             </a:r>
             <a:endParaRPr lang="en-US" sz="1300" dirty="0"/>
           </a:p>
@@ -6265,97 +6571,15 @@
             <a:r>
               <a:rPr lang="en-US" sz="1300" dirty="0">
                 <a:solidFill>
-                  <a:srgbClr val="1E293B"/>
-                </a:solidFill>
-                <a:latin typeface="Calibri" pitchFamily="34" charset="0"/>
-                <a:ea typeface="Calibri" pitchFamily="34" charset="-122"/>
-                <a:cs typeface="Calibri" pitchFamily="34" charset="-120"/>
-              </a:rPr>
-              <a:t>Router-on-a-stick med dot1Q</a:t>
+                  <a:srgbClr val="64748B"/>
+                </a:solidFill>
+                <a:latin typeface="Calibri" pitchFamily="34" charset="0"/>
+                <a:ea typeface="Calibri" pitchFamily="34" charset="-122"/>
+                <a:cs typeface="Calibri" pitchFamily="34" charset="-120"/>
+              </a:rPr>
+              <a:t>Secrets i .env — aldri i GitHub</a:t>
             </a:r>
             <a:endParaRPr lang="en-US" sz="1300" dirty="0"/>
-          </a:p>
-          <a:p>
-            <a:pPr marL="342900" indent="-342900">
-              <a:buSzPct val="100000"/>
-              <a:buChar char="•"/>
-            </a:pPr>
-            <a:r>
-              <a:rPr lang="en-US" sz="1300" dirty="0">
-                <a:solidFill>
-                  <a:srgbClr val="1E293B"/>
-                </a:solidFill>
-                <a:latin typeface="Calibri" pitchFamily="34" charset="0"/>
-                <a:ea typeface="Calibri" pitchFamily="34" charset="-122"/>
-                <a:cs typeface="Calibri" pitchFamily="34" charset="-120"/>
-              </a:rPr>
-              <a:t>Alle koblinger grønne — oppe</a:t>
-            </a:r>
-            <a:endParaRPr lang="en-US" sz="1300" dirty="0"/>
-          </a:p>
-        </p:txBody>
-      </p:sp>
-      <p:sp>
-        <p:nvSpPr>
-          <p:cNvPr id="6" name="Shape 3"/>
-          <p:cNvSpPr/>
-          <p:nvPr/>
-        </p:nvSpPr>
-        <p:spPr>
-          <a:xfrm>
-            <a:off x="5394960" y="3749040"/>
-            <a:ext cx="3474720" cy="548640"/>
-          </a:xfrm>
-          <a:prstGeom prst="rect">
-            <a:avLst/>
-          </a:prstGeom>
-          <a:solidFill>
-            <a:srgbClr val="16A34A"/>
-          </a:solidFill>
-          <a:ln w="12700">
-            <a:solidFill>
-              <a:srgbClr val="16A34A"/>
-            </a:solidFill>
-            <a:prstDash val="solid"/>
-          </a:ln>
-        </p:spPr>
-      </p:sp>
-      <p:sp>
-        <p:nvSpPr>
-          <p:cNvPr id="7" name="Text 4"/>
-          <p:cNvSpPr/>
-          <p:nvPr/>
-        </p:nvSpPr>
-        <p:spPr>
-          <a:xfrm>
-            <a:off x="5394960" y="3749040"/>
-            <a:ext cx="3474720" cy="548640"/>
-          </a:xfrm>
-          <a:prstGeom prst="rect">
-            <a:avLst/>
-          </a:prstGeom>
-          <a:noFill/>
-          <a:ln/>
-        </p:spPr>
-        <p:txBody>
-          <a:bodyPr wrap="square" lIns="0" tIns="0" rIns="0" bIns="0" rtlCol="0" anchor="ctr"/>
-          <a:lstStyle/>
-          <a:p>
-            <a:pPr algn="ctr" indent="0" marL="0">
-              <a:buNone/>
-            </a:pPr>
-            <a:r>
-              <a:rPr lang="en-US" sz="1500" b="1" dirty="0">
-                <a:solidFill>
-                  <a:srgbClr val="FFFFFF"/>
-                </a:solidFill>
-                <a:latin typeface="Calibri" pitchFamily="34" charset="0"/>
-                <a:ea typeface="Calibri" pitchFamily="34" charset="-122"/>
-                <a:cs typeface="Calibri" pitchFamily="34" charset="-120"/>
-              </a:rPr>
-              <a:t>Oppgave 2 fullført ✓</a:t>
-            </a:r>
-            <a:endParaRPr lang="en-US" sz="1500" dirty="0"/>
           </a:p>
         </p:txBody>
       </p:sp>
@@ -6449,7 +6673,7 @@
                 <a:ea typeface="Calibri" pitchFamily="34" charset="-122"/>
                 <a:cs typeface="Calibri" pitchFamily="34" charset="-120"/>
               </a:rPr>
-              <a:t>Drift — VLAN og router-konfigurasjon</a:t>
+              <a:t>Oppgave 1 — Web-løsning: Forside og innlogging</a:t>
             </a:r>
             <a:endParaRPr lang="en-US" sz="2800" dirty="0"/>
           </a:p>
@@ -6457,7 +6681,7 @@
       </p:sp>
       <p:pic>
         <p:nvPicPr>
-          <p:cNvPr id="4" name="Image 0" descr="C:\Eksamen_2026\bilder\show_vlan_brief.png">    </p:cNvPr>
+          <p:cNvPr id="4" name="Image 0" descr="C:\Eksamen_2026\bilder\web_forside.png">    </p:cNvPr>
           <p:cNvPicPr>
             <a:picLocks noChangeAspect="1"/>
           </p:cNvPicPr>
@@ -6481,7 +6705,7 @@
       </p:pic>
       <p:pic>
         <p:nvPicPr>
-          <p:cNvPr id="5" name="Image 1" descr="C:\Eksamen_2026\bilder\running_config.png">    </p:cNvPr>
+          <p:cNvPr id="5" name="Image 1" descr="C:\Eksamen_2026\bilder\login_web_side.png">    </p:cNvPr>
           <p:cNvPicPr>
             <a:picLocks noChangeAspect="1"/>
           </p:cNvPicPr>
@@ -6536,7 +6760,7 @@
                 <a:ea typeface="Calibri" pitchFamily="34" charset="-122"/>
                 <a:cs typeface="Calibri" pitchFamily="34" charset="-120"/>
               </a:rPr>
-              <a:t>show vlan brief — Switch0</a:t>
+              <a:t>Offentlig markedsføringsside — localhost:3000</a:t>
             </a:r>
             <a:endParaRPr lang="en-US" sz="1100" dirty="0"/>
           </a:p>
@@ -6575,7 +6799,7 @@
                 <a:ea typeface="Calibri" pitchFamily="34" charset="-122"/>
                 <a:cs typeface="Calibri" pitchFamily="34" charset="-120"/>
               </a:rPr>
-              <a:t>show running-config — Router0</a:t>
+              <a:t>Innloggingsside for kundeportal</a:t>
             </a:r>
             <a:endParaRPr lang="en-US" sz="1100" dirty="0"/>
           </a:p>
@@ -6671,7 +6895,7 @@
                 <a:ea typeface="Calibri" pitchFamily="34" charset="-122"/>
                 <a:cs typeface="Calibri" pitchFamily="34" charset="-120"/>
               </a:rPr>
-              <a:t>Drift — Isolasjon og IP-konfigurasjon bekreftet</a:t>
+              <a:t>Oppgave 1 — Kundeportal: Isolasjon bekreftet</a:t>
             </a:r>
             <a:endParaRPr lang="en-US" sz="2800" dirty="0"/>
           </a:p>
@@ -6679,7 +6903,7 @@
       </p:sp>
       <p:pic>
         <p:nvPicPr>
-          <p:cNvPr id="4" name="Image 0" descr="C:\Eksamen_2026\bilder\ping_test.png">    </p:cNvPr>
+          <p:cNvPr id="4" name="Image 0" descr="C:\Eksamen_2026\bilder\bedrift_data.png">    </p:cNvPr>
           <p:cNvPicPr>
             <a:picLocks noChangeAspect="1"/>
           </p:cNvPicPr>
@@ -6694,7 +6918,7 @@
         <p:spPr>
           <a:xfrm>
             <a:off x="457200" y="1005840"/>
-            <a:ext cx="4114800" cy="3017520"/>
+            <a:ext cx="4114800" cy="2926080"/>
           </a:xfrm>
           <a:prstGeom prst="rect">
             <a:avLst/>
@@ -6703,7 +6927,7 @@
       </p:pic>
       <p:pic>
         <p:nvPicPr>
-          <p:cNvPr id="5" name="Image 1" descr="C:\Eksamen_2026\bilder\ip_config.png">    </p:cNvPr>
+          <p:cNvPr id="5" name="Image 1" descr="C:\Eksamen_2026\bilder\annen_bedrift_data.png">    </p:cNvPr>
           <p:cNvPicPr>
             <a:picLocks noChangeAspect="1"/>
           </p:cNvPicPr>
@@ -6718,7 +6942,7 @@
         <p:spPr>
           <a:xfrm>
             <a:off x="4754880" y="1005840"/>
-            <a:ext cx="4114800" cy="3017520"/>
+            <a:ext cx="4114800" cy="2926080"/>
           </a:xfrm>
           <a:prstGeom prst="rect">
             <a:avLst/>
@@ -6733,8 +6957,8 @@
         </p:nvSpPr>
         <p:spPr>
           <a:xfrm>
-            <a:off x="457200" y="4114800"/>
-            <a:ext cx="4114800" cy="365760"/>
+            <a:off x="457200" y="3977640"/>
+            <a:ext cx="4114800" cy="320040"/>
           </a:xfrm>
           <a:prstGeom prst="rect">
             <a:avLst/>
@@ -6758,7 +6982,7 @@
                 <a:ea typeface="Calibri" pitchFamily="34" charset="-122"/>
                 <a:cs typeface="Calibri" pitchFamily="34" charset="-120"/>
               </a:rPr>
-              <a:t>Ping-test: intra-VLAN Reply ✓ / inter-VLAN Timed out ✓</a:t>
+              <a:t>bedrift1 → Bedrift AS (VLAN 10)</a:t>
             </a:r>
             <a:endParaRPr lang="en-US" sz="1100" dirty="0"/>
           </a:p>
@@ -6772,8 +6996,8 @@
         </p:nvSpPr>
         <p:spPr>
           <a:xfrm>
-            <a:off x="4754880" y="4114800"/>
-            <a:ext cx="4114800" cy="365760"/>
+            <a:off x="4754880" y="3977640"/>
+            <a:ext cx="4114800" cy="320040"/>
           </a:xfrm>
           <a:prstGeom prst="rect">
             <a:avLst/>
@@ -6797,9 +7021,73 @@
                 <a:ea typeface="Calibri" pitchFamily="34" charset="-122"/>
                 <a:cs typeface="Calibri" pitchFamily="34" charset="-120"/>
               </a:rPr>
-              <a:t>IP-konfig PC0 — 192.168.10.2 / gateway 192.168.10.1</a:t>
+              <a:t>bedrift2 → Konsulent AS (VLAN 20)</a:t>
             </a:r>
             <a:endParaRPr lang="en-US" sz="1100" dirty="0"/>
+          </a:p>
+        </p:txBody>
+      </p:sp>
+      <p:sp>
+        <p:nvSpPr>
+          <p:cNvPr id="8" name="Shape 4"/>
+          <p:cNvSpPr/>
+          <p:nvPr/>
+        </p:nvSpPr>
+        <p:spPr>
+          <a:xfrm>
+            <a:off x="457200" y="4370832"/>
+            <a:ext cx="8229600" cy="411480"/>
+          </a:xfrm>
+          <a:prstGeom prst="rect">
+            <a:avLst/>
+          </a:prstGeom>
+          <a:solidFill>
+            <a:srgbClr val="16A34A"/>
+          </a:solidFill>
+          <a:ln w="12700">
+            <a:solidFill>
+              <a:srgbClr val="16A34A"/>
+            </a:solidFill>
+            <a:prstDash val="solid"/>
+          </a:ln>
+        </p:spPr>
+      </p:sp>
+      <p:sp>
+        <p:nvSpPr>
+          <p:cNvPr id="9" name="Text 5"/>
+          <p:cNvSpPr/>
+          <p:nvPr/>
+        </p:nvSpPr>
+        <p:spPr>
+          <a:xfrm>
+            <a:off x="457200" y="4370832"/>
+            <a:ext cx="8229600" cy="411480"/>
+          </a:xfrm>
+          <a:prstGeom prst="rect">
+            <a:avLst/>
+          </a:prstGeom>
+          <a:noFill/>
+          <a:ln/>
+        </p:spPr>
+        <p:txBody>
+          <a:bodyPr wrap="square" lIns="0" tIns="0" rIns="0" bIns="0" rtlCol="0" anchor="ctr"/>
+          <a:lstStyle/>
+          <a:p>
+            <a:pPr algn="ctr" indent="0" marL="0">
+              <a:buNone/>
+            </a:pPr>
+            <a:r>
+              <a:rPr lang="en-US" sz="1300" b="1" dirty="0">
+                <a:solidFill>
+                  <a:srgbClr val="FFFFFF"/>
+                </a:solidFill>
+                <a:latin typeface="Calibri" pitchFamily="34" charset="0"/>
+                <a:ea typeface="Calibri" pitchFamily="34" charset="-122"/>
+                <a:cs typeface="Calibri" pitchFamily="34" charset="-120"/>
+              </a:rPr>
+              <a:t>Hver bedrift ser kun egne data — isolasjon på nett- og applikasjonsnivå ✓</a:t>
+            </a:r>
+            <a:endParaRPr lang="en-US" sz="1300" dirty="0"/>
           </a:p>
         </p:txBody>
       </p:sp>
@@ -6893,1034 +7181,6 @@
                 <a:ea typeface="Calibri" pitchFamily="34" charset="-122"/>
                 <a:cs typeface="Calibri" pitchFamily="34" charset="-120"/>
               </a:rPr>
-              <a:t>Oppgave 1 — Utvikling: Arkitektur</a:t>
-            </a:r>
-            <a:endParaRPr lang="en-US" sz="2800" dirty="0"/>
-          </a:p>
-        </p:txBody>
-      </p:sp>
-      <p:sp>
-        <p:nvSpPr>
-          <p:cNvPr id="4" name="Shape 2"/>
-          <p:cNvSpPr/>
-          <p:nvPr/>
-        </p:nvSpPr>
-        <p:spPr>
-          <a:xfrm>
-            <a:off x="1371600" y="1097280"/>
-            <a:ext cx="6400800" cy="777240"/>
-          </a:xfrm>
-          <a:prstGeom prst="rect">
-            <a:avLst/>
-          </a:prstGeom>
-          <a:solidFill>
-            <a:srgbClr val="1C7293"/>
-          </a:solidFill>
-          <a:ln w="12700">
-            <a:solidFill>
-              <a:srgbClr val="1C7293"/>
-            </a:solidFill>
-            <a:prstDash val="solid"/>
-          </a:ln>
-          <a:effectLst>
-            <a:outerShdw sx="100000" sy="100000" kx="0" ky="0" algn="bl" rotWithShape="0" blurRad="101600" dist="38100" dir="8100000">
-              <a:srgbClr val="000000">
-                <a:alpha val="15000"/>
-              </a:srgbClr>
-            </a:outerShdw>
-          </a:effectLst>
-        </p:spPr>
-      </p:sp>
-      <p:sp>
-        <p:nvSpPr>
-          <p:cNvPr id="5" name="Text 3"/>
-          <p:cNvSpPr/>
-          <p:nvPr/>
-        </p:nvSpPr>
-        <p:spPr>
-          <a:xfrm>
-            <a:off x="1371600" y="1097280"/>
-            <a:ext cx="3200400" cy="777240"/>
-          </a:xfrm>
-          <a:prstGeom prst="rect">
-            <a:avLst/>
-          </a:prstGeom>
-          <a:noFill/>
-          <a:ln/>
-        </p:spPr>
-        <p:txBody>
-          <a:bodyPr wrap="square" lIns="0" tIns="0" rIns="0" bIns="0" rtlCol="0" anchor="ctr"/>
-          <a:lstStyle/>
-          <a:p>
-            <a:pPr algn="ctr" indent="0" marL="0">
-              <a:buNone/>
-            </a:pPr>
-            <a:r>
-              <a:rPr lang="en-US" sz="1800" b="1" dirty="0">
-                <a:solidFill>
-                  <a:srgbClr val="FFFFFF"/>
-                </a:solidFill>
-                <a:latin typeface="Calibri" pitchFamily="34" charset="0"/>
-                <a:ea typeface="Calibri" pitchFamily="34" charset="-122"/>
-                <a:cs typeface="Calibri" pitchFamily="34" charset="-120"/>
-              </a:rPr>
-              <a:t>Nettleser</a:t>
-            </a:r>
-            <a:endParaRPr lang="en-US" sz="1800" dirty="0"/>
-          </a:p>
-        </p:txBody>
-      </p:sp>
-      <p:sp>
-        <p:nvSpPr>
-          <p:cNvPr id="6" name="Text 4"/>
-          <p:cNvSpPr/>
-          <p:nvPr/>
-        </p:nvSpPr>
-        <p:spPr>
-          <a:xfrm>
-            <a:off x="4572000" y="1097280"/>
-            <a:ext cx="3200400" cy="777240"/>
-          </a:xfrm>
-          <a:prstGeom prst="rect">
-            <a:avLst/>
-          </a:prstGeom>
-          <a:noFill/>
-          <a:ln/>
-        </p:spPr>
-        <p:txBody>
-          <a:bodyPr wrap="square" lIns="0" tIns="0" rIns="0" bIns="0" rtlCol="0" anchor="ctr"/>
-          <a:lstStyle/>
-          <a:p>
-            <a:pPr algn="ctr" indent="0" marL="0">
-              <a:buNone/>
-            </a:pPr>
-            <a:r>
-              <a:rPr lang="en-US" sz="1400" dirty="0">
-                <a:solidFill>
-                  <a:srgbClr val="A8D4F5"/>
-                </a:solidFill>
-                <a:latin typeface="Calibri" pitchFamily="34" charset="0"/>
-                <a:ea typeface="Calibri" pitchFamily="34" charset="-122"/>
-                <a:cs typeface="Calibri" pitchFamily="34" charset="-120"/>
-              </a:rPr>
-              <a:t>HTML + CSS (plain)</a:t>
-            </a:r>
-            <a:endParaRPr lang="en-US" sz="1400" dirty="0"/>
-          </a:p>
-        </p:txBody>
-      </p:sp>
-      <p:sp>
-        <p:nvSpPr>
-          <p:cNvPr id="7" name="Shape 5"/>
-          <p:cNvSpPr/>
-          <p:nvPr/>
-        </p:nvSpPr>
-        <p:spPr>
-          <a:xfrm>
-            <a:off x="1371600" y="2103120"/>
-            <a:ext cx="6400800" cy="777240"/>
-          </a:xfrm>
-          <a:prstGeom prst="rect">
-            <a:avLst/>
-          </a:prstGeom>
-          <a:solidFill>
-            <a:srgbClr val="065A82"/>
-          </a:solidFill>
-          <a:ln w="12700">
-            <a:solidFill>
-              <a:srgbClr val="065A82"/>
-            </a:solidFill>
-            <a:prstDash val="solid"/>
-          </a:ln>
-          <a:effectLst>
-            <a:outerShdw sx="100000" sy="100000" kx="0" ky="0" algn="bl" rotWithShape="0" blurRad="101600" dist="38100" dir="8100000">
-              <a:srgbClr val="000000">
-                <a:alpha val="15000"/>
-              </a:srgbClr>
-            </a:outerShdw>
-          </a:effectLst>
-        </p:spPr>
-      </p:sp>
-      <p:sp>
-        <p:nvSpPr>
-          <p:cNvPr id="8" name="Text 6"/>
-          <p:cNvSpPr/>
-          <p:nvPr/>
-        </p:nvSpPr>
-        <p:spPr>
-          <a:xfrm>
-            <a:off x="1371600" y="2103120"/>
-            <a:ext cx="3200400" cy="777240"/>
-          </a:xfrm>
-          <a:prstGeom prst="rect">
-            <a:avLst/>
-          </a:prstGeom>
-          <a:noFill/>
-          <a:ln/>
-        </p:spPr>
-        <p:txBody>
-          <a:bodyPr wrap="square" lIns="0" tIns="0" rIns="0" bIns="0" rtlCol="0" anchor="ctr"/>
-          <a:lstStyle/>
-          <a:p>
-            <a:pPr algn="ctr" indent="0" marL="0">
-              <a:buNone/>
-            </a:pPr>
-            <a:r>
-              <a:rPr lang="en-US" sz="1800" b="1" dirty="0">
-                <a:solidFill>
-                  <a:srgbClr val="FFFFFF"/>
-                </a:solidFill>
-                <a:latin typeface="Calibri" pitchFamily="34" charset="0"/>
-                <a:ea typeface="Calibri" pitchFamily="34" charset="-122"/>
-                <a:cs typeface="Calibri" pitchFamily="34" charset="-120"/>
-              </a:rPr>
-              <a:t>Backend</a:t>
-            </a:r>
-            <a:endParaRPr lang="en-US" sz="1800" dirty="0"/>
-          </a:p>
-        </p:txBody>
-      </p:sp>
-      <p:sp>
-        <p:nvSpPr>
-          <p:cNvPr id="9" name="Text 7"/>
-          <p:cNvSpPr/>
-          <p:nvPr/>
-        </p:nvSpPr>
-        <p:spPr>
-          <a:xfrm>
-            <a:off x="4572000" y="2103120"/>
-            <a:ext cx="3200400" cy="777240"/>
-          </a:xfrm>
-          <a:prstGeom prst="rect">
-            <a:avLst/>
-          </a:prstGeom>
-          <a:noFill/>
-          <a:ln/>
-        </p:spPr>
-        <p:txBody>
-          <a:bodyPr wrap="square" lIns="0" tIns="0" rIns="0" bIns="0" rtlCol="0" anchor="ctr"/>
-          <a:lstStyle/>
-          <a:p>
-            <a:pPr algn="ctr" indent="0" marL="0">
-              <a:buNone/>
-            </a:pPr>
-            <a:r>
-              <a:rPr lang="en-US" sz="1400" dirty="0">
-                <a:solidFill>
-                  <a:srgbClr val="A8D4F5"/>
-                </a:solidFill>
-                <a:latin typeface="Calibri" pitchFamily="34" charset="0"/>
-                <a:ea typeface="Calibri" pitchFamily="34" charset="-122"/>
-                <a:cs typeface="Calibri" pitchFamily="34" charset="-120"/>
-              </a:rPr>
-              <a:t>Node.js + Express</a:t>
-            </a:r>
-            <a:endParaRPr lang="en-US" sz="1400" dirty="0"/>
-          </a:p>
-        </p:txBody>
-      </p:sp>
-      <p:sp>
-        <p:nvSpPr>
-          <p:cNvPr id="10" name="Shape 8"/>
-          <p:cNvSpPr/>
-          <p:nvPr/>
-        </p:nvSpPr>
-        <p:spPr>
-          <a:xfrm>
-            <a:off x="1371600" y="3108960"/>
-            <a:ext cx="6400800" cy="777240"/>
-          </a:xfrm>
-          <a:prstGeom prst="rect">
-            <a:avLst/>
-          </a:prstGeom>
-          <a:solidFill>
-            <a:srgbClr val="21295C"/>
-          </a:solidFill>
-          <a:ln w="12700">
-            <a:solidFill>
-              <a:srgbClr val="21295C"/>
-            </a:solidFill>
-            <a:prstDash val="solid"/>
-          </a:ln>
-          <a:effectLst>
-            <a:outerShdw sx="100000" sy="100000" kx="0" ky="0" algn="bl" rotWithShape="0" blurRad="101600" dist="38100" dir="8100000">
-              <a:srgbClr val="000000">
-                <a:alpha val="15000"/>
-              </a:srgbClr>
-            </a:outerShdw>
-          </a:effectLst>
-        </p:spPr>
-      </p:sp>
-      <p:sp>
-        <p:nvSpPr>
-          <p:cNvPr id="11" name="Text 9"/>
-          <p:cNvSpPr/>
-          <p:nvPr/>
-        </p:nvSpPr>
-        <p:spPr>
-          <a:xfrm>
-            <a:off x="1371600" y="3108960"/>
-            <a:ext cx="3200400" cy="777240"/>
-          </a:xfrm>
-          <a:prstGeom prst="rect">
-            <a:avLst/>
-          </a:prstGeom>
-          <a:noFill/>
-          <a:ln/>
-        </p:spPr>
-        <p:txBody>
-          <a:bodyPr wrap="square" lIns="0" tIns="0" rIns="0" bIns="0" rtlCol="0" anchor="ctr"/>
-          <a:lstStyle/>
-          <a:p>
-            <a:pPr algn="ctr" indent="0" marL="0">
-              <a:buNone/>
-            </a:pPr>
-            <a:r>
-              <a:rPr lang="en-US" sz="1800" b="1" dirty="0">
-                <a:solidFill>
-                  <a:srgbClr val="FFFFFF"/>
-                </a:solidFill>
-                <a:latin typeface="Calibri" pitchFamily="34" charset="0"/>
-                <a:ea typeface="Calibri" pitchFamily="34" charset="-122"/>
-                <a:cs typeface="Calibri" pitchFamily="34" charset="-120"/>
-              </a:rPr>
-              <a:t>Database</a:t>
-            </a:r>
-            <a:endParaRPr lang="en-US" sz="1800" dirty="0"/>
-          </a:p>
-        </p:txBody>
-      </p:sp>
-      <p:sp>
-        <p:nvSpPr>
-          <p:cNvPr id="12" name="Text 10"/>
-          <p:cNvSpPr/>
-          <p:nvPr/>
-        </p:nvSpPr>
-        <p:spPr>
-          <a:xfrm>
-            <a:off x="4572000" y="3108960"/>
-            <a:ext cx="3200400" cy="777240"/>
-          </a:xfrm>
-          <a:prstGeom prst="rect">
-            <a:avLst/>
-          </a:prstGeom>
-          <a:noFill/>
-          <a:ln/>
-        </p:spPr>
-        <p:txBody>
-          <a:bodyPr wrap="square" lIns="0" tIns="0" rIns="0" bIns="0" rtlCol="0" anchor="ctr"/>
-          <a:lstStyle/>
-          <a:p>
-            <a:pPr algn="ctr" indent="0" marL="0">
-              <a:buNone/>
-            </a:pPr>
-            <a:r>
-              <a:rPr lang="en-US" sz="1400" dirty="0">
-                <a:solidFill>
-                  <a:srgbClr val="A8D4F5"/>
-                </a:solidFill>
-                <a:latin typeface="Calibri" pitchFamily="34" charset="0"/>
-                <a:ea typeface="Calibri" pitchFamily="34" charset="-122"/>
-                <a:cs typeface="Calibri" pitchFamily="34" charset="-120"/>
-              </a:rPr>
-              <a:t>MariaDB i Docker</a:t>
-            </a:r>
-            <a:endParaRPr lang="en-US" sz="1400" dirty="0"/>
-          </a:p>
-        </p:txBody>
-      </p:sp>
-      <p:sp>
-        <p:nvSpPr>
-          <p:cNvPr id="13" name="Text 11"/>
-          <p:cNvSpPr/>
-          <p:nvPr/>
-        </p:nvSpPr>
-        <p:spPr>
-          <a:xfrm>
-            <a:off x="457200" y="4160520"/>
-            <a:ext cx="8229600" cy="777240"/>
-          </a:xfrm>
-          <a:prstGeom prst="rect">
-            <a:avLst/>
-          </a:prstGeom>
-          <a:noFill/>
-          <a:ln/>
-        </p:spPr>
-        <p:txBody>
-          <a:bodyPr wrap="square" rtlCol="0" anchor="ctr"/>
-          <a:lstStyle/>
-          <a:p>
-            <a:pPr marL="342900" indent="-342900">
-              <a:buSzPct val="100000"/>
-              <a:buChar char="•"/>
-            </a:pPr>
-            <a:r>
-              <a:rPr lang="en-US" sz="1300" dirty="0">
-                <a:solidFill>
-                  <a:srgbClr val="64748B"/>
-                </a:solidFill>
-                <a:latin typeface="Calibri" pitchFamily="34" charset="0"/>
-                <a:ea typeface="Calibri" pitchFamily="34" charset="-122"/>
-                <a:cs typeface="Calibri" pitchFamily="34" charset="-120"/>
-              </a:rPr>
-              <a:t>docker compose up --build — én kommando</a:t>
-            </a:r>
-            <a:endParaRPr lang="en-US" sz="1300" dirty="0"/>
-          </a:p>
-          <a:p>
-            <a:pPr marL="342900" indent="-342900">
-              <a:buSzPct val="100000"/>
-              <a:buChar char="•"/>
-            </a:pPr>
-            <a:r>
-              <a:rPr lang="en-US" sz="1300" dirty="0">
-                <a:solidFill>
-                  <a:srgbClr val="64748B"/>
-                </a:solidFill>
-                <a:latin typeface="Calibri" pitchFamily="34" charset="0"/>
-                <a:ea typeface="Calibri" pitchFamily="34" charset="-122"/>
-                <a:cs typeface="Calibri" pitchFamily="34" charset="-120"/>
-              </a:rPr>
-              <a:t>Session-basert auth med bcrypt</a:t>
-            </a:r>
-            <a:endParaRPr lang="en-US" sz="1300" dirty="0"/>
-          </a:p>
-          <a:p>
-            <a:pPr marL="342900" indent="-342900">
-              <a:buSzPct val="100000"/>
-              <a:buChar char="•"/>
-            </a:pPr>
-            <a:r>
-              <a:rPr lang="en-US" sz="1300" dirty="0">
-                <a:solidFill>
-                  <a:srgbClr val="64748B"/>
-                </a:solidFill>
-                <a:latin typeface="Calibri" pitchFamily="34" charset="0"/>
-                <a:ea typeface="Calibri" pitchFamily="34" charset="-122"/>
-                <a:cs typeface="Calibri" pitchFamily="34" charset="-120"/>
-              </a:rPr>
-              <a:t>Hver bedrift ser kun egne data</a:t>
-            </a:r>
-            <a:endParaRPr lang="en-US" sz="1300" dirty="0"/>
-          </a:p>
-          <a:p>
-            <a:pPr marL="342900" indent="-342900">
-              <a:buSzPct val="100000"/>
-              <a:buChar char="•"/>
-            </a:pPr>
-            <a:r>
-              <a:rPr lang="en-US" sz="1300" dirty="0">
-                <a:solidFill>
-                  <a:srgbClr val="64748B"/>
-                </a:solidFill>
-                <a:latin typeface="Calibri" pitchFamily="34" charset="0"/>
-                <a:ea typeface="Calibri" pitchFamily="34" charset="-122"/>
-                <a:cs typeface="Calibri" pitchFamily="34" charset="-120"/>
-              </a:rPr>
-              <a:t>Secrets i .env — aldri i GitHub</a:t>
-            </a:r>
-            <a:endParaRPr lang="en-US" sz="1300" dirty="0"/>
-          </a:p>
-        </p:txBody>
-      </p:sp>
-    </p:spTree>
-  </p:cSld>
-  <p:clrMapOvr>
-    <a:masterClrMapping/>
-  </p:clrMapOvr>
-</p:sld>
-</file>
-
-<file path=ppt/slides/slide7.xml><?xml version="1.0" encoding="utf-8"?>
-<p:sld xmlns:a="http://schemas.openxmlformats.org/drawingml/2006/main" xmlns:r="http://schemas.openxmlformats.org/officeDocument/2006/relationships" xmlns:p="http://schemas.openxmlformats.org/presentationml/2006/main">
-  <p:cSld name="Slide 7">
-    <p:bg>
-      <p:bgPr>
-        <a:solidFill>
-          <a:srgbClr val="F0F7FF"/>
-        </a:solidFill>
-      </p:bgPr>
-    </p:bg>
-    <p:spTree>
-      <p:nvGrpSpPr>
-        <p:cNvPr id="1" name=""/>
-        <p:cNvGrpSpPr/>
-        <p:nvPr/>
-      </p:nvGrpSpPr>
-      <p:grpSpPr>
-        <a:xfrm>
-          <a:off x="0" y="0"/>
-          <a:ext cx="0" cy="0"/>
-          <a:chOff x="0" y="0"/>
-          <a:chExt cx="0" cy="0"/>
-        </a:xfrm>
-      </p:grpSpPr>
-      <p:sp>
-        <p:nvSpPr>
-          <p:cNvPr id="2" name="Shape 0"/>
-          <p:cNvSpPr/>
-          <p:nvPr/>
-        </p:nvSpPr>
-        <p:spPr>
-          <a:xfrm>
-            <a:off x="0" y="0"/>
-            <a:ext cx="9144000" cy="914400"/>
-          </a:xfrm>
-          <a:prstGeom prst="rect">
-            <a:avLst/>
-          </a:prstGeom>
-          <a:solidFill>
-            <a:srgbClr val="065A82"/>
-          </a:solidFill>
-          <a:ln w="12700">
-            <a:solidFill>
-              <a:srgbClr val="065A82"/>
-            </a:solidFill>
-            <a:prstDash val="solid"/>
-          </a:ln>
-        </p:spPr>
-      </p:sp>
-      <p:sp>
-        <p:nvSpPr>
-          <p:cNvPr id="3" name="Text 1"/>
-          <p:cNvSpPr/>
-          <p:nvPr/>
-        </p:nvSpPr>
-        <p:spPr>
-          <a:xfrm>
-            <a:off x="457200" y="137160"/>
-            <a:ext cx="8229600" cy="640080"/>
-          </a:xfrm>
-          <a:prstGeom prst="rect">
-            <a:avLst/>
-          </a:prstGeom>
-          <a:noFill/>
-          <a:ln/>
-        </p:spPr>
-        <p:txBody>
-          <a:bodyPr wrap="square" lIns="0" tIns="0" rIns="0" bIns="0" rtlCol="0" anchor="ctr"/>
-          <a:lstStyle/>
-          <a:p>
-            <a:pPr indent="0" marL="0">
-              <a:buNone/>
-            </a:pPr>
-            <a:r>
-              <a:rPr lang="en-US" sz="2800" b="1" dirty="0">
-                <a:solidFill>
-                  <a:srgbClr val="FFFFFF"/>
-                </a:solidFill>
-                <a:latin typeface="Calibri" pitchFamily="34" charset="0"/>
-                <a:ea typeface="Calibri" pitchFamily="34" charset="-122"/>
-                <a:cs typeface="Calibri" pitchFamily="34" charset="-120"/>
-              </a:rPr>
-              <a:t>Oppgave 1 — Web-løsning: Forside og innlogging</a:t>
-            </a:r>
-            <a:endParaRPr lang="en-US" sz="2800" dirty="0"/>
-          </a:p>
-        </p:txBody>
-      </p:sp>
-      <p:pic>
-        <p:nvPicPr>
-          <p:cNvPr id="4" name="Image 0" descr="C:\Eksamen_2026\bilder\web_forside.png">    </p:cNvPr>
-          <p:cNvPicPr>
-            <a:picLocks noChangeAspect="1"/>
-          </p:cNvPicPr>
-          <p:nvPr/>
-        </p:nvPicPr>
-        <p:blipFill>
-          <a:blip r:embed="rId1"/>
-          <a:stretch>
-            <a:fillRect/>
-          </a:stretch>
-        </p:blipFill>
-        <p:spPr>
-          <a:xfrm>
-            <a:off x="457200" y="1005840"/>
-            <a:ext cx="4114800" cy="3017520"/>
-          </a:xfrm>
-          <a:prstGeom prst="rect">
-            <a:avLst/>
-          </a:prstGeom>
-        </p:spPr>
-      </p:pic>
-      <p:pic>
-        <p:nvPicPr>
-          <p:cNvPr id="5" name="Image 1" descr="C:\Eksamen_2026\bilder\login_web_side.png">    </p:cNvPr>
-          <p:cNvPicPr>
-            <a:picLocks noChangeAspect="1"/>
-          </p:cNvPicPr>
-          <p:nvPr/>
-        </p:nvPicPr>
-        <p:blipFill>
-          <a:blip r:embed="rId2"/>
-          <a:stretch>
-            <a:fillRect/>
-          </a:stretch>
-        </p:blipFill>
-        <p:spPr>
-          <a:xfrm>
-            <a:off x="4754880" y="1005840"/>
-            <a:ext cx="4114800" cy="3017520"/>
-          </a:xfrm>
-          <a:prstGeom prst="rect">
-            <a:avLst/>
-          </a:prstGeom>
-        </p:spPr>
-      </p:pic>
-      <p:sp>
-        <p:nvSpPr>
-          <p:cNvPr id="6" name="Text 2"/>
-          <p:cNvSpPr/>
-          <p:nvPr/>
-        </p:nvSpPr>
-        <p:spPr>
-          <a:xfrm>
-            <a:off x="457200" y="4114800"/>
-            <a:ext cx="4114800" cy="365760"/>
-          </a:xfrm>
-          <a:prstGeom prst="rect">
-            <a:avLst/>
-          </a:prstGeom>
-          <a:noFill/>
-          <a:ln/>
-        </p:spPr>
-        <p:txBody>
-          <a:bodyPr wrap="square" lIns="0" tIns="0" rIns="0" bIns="0" rtlCol="0" anchor="ctr"/>
-          <a:lstStyle/>
-          <a:p>
-            <a:pPr algn="ctr" indent="0" marL="0">
-              <a:buNone/>
-            </a:pPr>
-            <a:r>
-              <a:rPr lang="en-US" sz="1100" i="1" dirty="0">
-                <a:solidFill>
-                  <a:srgbClr val="64748B"/>
-                </a:solidFill>
-                <a:latin typeface="Calibri" pitchFamily="34" charset="0"/>
-                <a:ea typeface="Calibri" pitchFamily="34" charset="-122"/>
-                <a:cs typeface="Calibri" pitchFamily="34" charset="-120"/>
-              </a:rPr>
-              <a:t>Offentlig markedsføringsside — localhost:3000</a:t>
-            </a:r>
-            <a:endParaRPr lang="en-US" sz="1100" dirty="0"/>
-          </a:p>
-        </p:txBody>
-      </p:sp>
-      <p:sp>
-        <p:nvSpPr>
-          <p:cNvPr id="7" name="Text 3"/>
-          <p:cNvSpPr/>
-          <p:nvPr/>
-        </p:nvSpPr>
-        <p:spPr>
-          <a:xfrm>
-            <a:off x="4754880" y="4114800"/>
-            <a:ext cx="4114800" cy="365760"/>
-          </a:xfrm>
-          <a:prstGeom prst="rect">
-            <a:avLst/>
-          </a:prstGeom>
-          <a:noFill/>
-          <a:ln/>
-        </p:spPr>
-        <p:txBody>
-          <a:bodyPr wrap="square" lIns="0" tIns="0" rIns="0" bIns="0" rtlCol="0" anchor="ctr"/>
-          <a:lstStyle/>
-          <a:p>
-            <a:pPr algn="ctr" indent="0" marL="0">
-              <a:buNone/>
-            </a:pPr>
-            <a:r>
-              <a:rPr lang="en-US" sz="1100" i="1" dirty="0">
-                <a:solidFill>
-                  <a:srgbClr val="64748B"/>
-                </a:solidFill>
-                <a:latin typeface="Calibri" pitchFamily="34" charset="0"/>
-                <a:ea typeface="Calibri" pitchFamily="34" charset="-122"/>
-                <a:cs typeface="Calibri" pitchFamily="34" charset="-120"/>
-              </a:rPr>
-              <a:t>Innloggingsside for kundeportal</a:t>
-            </a:r>
-            <a:endParaRPr lang="en-US" sz="1100" dirty="0"/>
-          </a:p>
-        </p:txBody>
-      </p:sp>
-    </p:spTree>
-  </p:cSld>
-  <p:clrMapOvr>
-    <a:masterClrMapping/>
-  </p:clrMapOvr>
-</p:sld>
-</file>
-
-<file path=ppt/slides/slide8.xml><?xml version="1.0" encoding="utf-8"?>
-<p:sld xmlns:a="http://schemas.openxmlformats.org/drawingml/2006/main" xmlns:r="http://schemas.openxmlformats.org/officeDocument/2006/relationships" xmlns:p="http://schemas.openxmlformats.org/presentationml/2006/main">
-  <p:cSld name="Slide 8">
-    <p:bg>
-      <p:bgPr>
-        <a:solidFill>
-          <a:srgbClr val="F0F7FF"/>
-        </a:solidFill>
-      </p:bgPr>
-    </p:bg>
-    <p:spTree>
-      <p:nvGrpSpPr>
-        <p:cNvPr id="1" name=""/>
-        <p:cNvGrpSpPr/>
-        <p:nvPr/>
-      </p:nvGrpSpPr>
-      <p:grpSpPr>
-        <a:xfrm>
-          <a:off x="0" y="0"/>
-          <a:ext cx="0" cy="0"/>
-          <a:chOff x="0" y="0"/>
-          <a:chExt cx="0" cy="0"/>
-        </a:xfrm>
-      </p:grpSpPr>
-      <p:sp>
-        <p:nvSpPr>
-          <p:cNvPr id="2" name="Shape 0"/>
-          <p:cNvSpPr/>
-          <p:nvPr/>
-        </p:nvSpPr>
-        <p:spPr>
-          <a:xfrm>
-            <a:off x="0" y="0"/>
-            <a:ext cx="9144000" cy="914400"/>
-          </a:xfrm>
-          <a:prstGeom prst="rect">
-            <a:avLst/>
-          </a:prstGeom>
-          <a:solidFill>
-            <a:srgbClr val="065A82"/>
-          </a:solidFill>
-          <a:ln w="12700">
-            <a:solidFill>
-              <a:srgbClr val="065A82"/>
-            </a:solidFill>
-            <a:prstDash val="solid"/>
-          </a:ln>
-        </p:spPr>
-      </p:sp>
-      <p:sp>
-        <p:nvSpPr>
-          <p:cNvPr id="3" name="Text 1"/>
-          <p:cNvSpPr/>
-          <p:nvPr/>
-        </p:nvSpPr>
-        <p:spPr>
-          <a:xfrm>
-            <a:off x="457200" y="137160"/>
-            <a:ext cx="8229600" cy="640080"/>
-          </a:xfrm>
-          <a:prstGeom prst="rect">
-            <a:avLst/>
-          </a:prstGeom>
-          <a:noFill/>
-          <a:ln/>
-        </p:spPr>
-        <p:txBody>
-          <a:bodyPr wrap="square" lIns="0" tIns="0" rIns="0" bIns="0" rtlCol="0" anchor="ctr"/>
-          <a:lstStyle/>
-          <a:p>
-            <a:pPr indent="0" marL="0">
-              <a:buNone/>
-            </a:pPr>
-            <a:r>
-              <a:rPr lang="en-US" sz="2800" b="1" dirty="0">
-                <a:solidFill>
-                  <a:srgbClr val="FFFFFF"/>
-                </a:solidFill>
-                <a:latin typeface="Calibri" pitchFamily="34" charset="0"/>
-                <a:ea typeface="Calibri" pitchFamily="34" charset="-122"/>
-                <a:cs typeface="Calibri" pitchFamily="34" charset="-120"/>
-              </a:rPr>
-              <a:t>Oppgave 1 — Kundeportal: Isolasjon bekreftet</a:t>
-            </a:r>
-            <a:endParaRPr lang="en-US" sz="2800" dirty="0"/>
-          </a:p>
-        </p:txBody>
-      </p:sp>
-      <p:pic>
-        <p:nvPicPr>
-          <p:cNvPr id="4" name="Image 0" descr="C:\Eksamen_2026\bilder\bedrift_data.png">    </p:cNvPr>
-          <p:cNvPicPr>
-            <a:picLocks noChangeAspect="1"/>
-          </p:cNvPicPr>
-          <p:nvPr/>
-        </p:nvPicPr>
-        <p:blipFill>
-          <a:blip r:embed="rId1"/>
-          <a:stretch>
-            <a:fillRect/>
-          </a:stretch>
-        </p:blipFill>
-        <p:spPr>
-          <a:xfrm>
-            <a:off x="457200" y="1005840"/>
-            <a:ext cx="4114800" cy="2926080"/>
-          </a:xfrm>
-          <a:prstGeom prst="rect">
-            <a:avLst/>
-          </a:prstGeom>
-        </p:spPr>
-      </p:pic>
-      <p:pic>
-        <p:nvPicPr>
-          <p:cNvPr id="5" name="Image 1" descr="C:\Eksamen_2026\bilder\annen_bedrift_data.png">    </p:cNvPr>
-          <p:cNvPicPr>
-            <a:picLocks noChangeAspect="1"/>
-          </p:cNvPicPr>
-          <p:nvPr/>
-        </p:nvPicPr>
-        <p:blipFill>
-          <a:blip r:embed="rId2"/>
-          <a:stretch>
-            <a:fillRect/>
-          </a:stretch>
-        </p:blipFill>
-        <p:spPr>
-          <a:xfrm>
-            <a:off x="4754880" y="1005840"/>
-            <a:ext cx="4114800" cy="2926080"/>
-          </a:xfrm>
-          <a:prstGeom prst="rect">
-            <a:avLst/>
-          </a:prstGeom>
-        </p:spPr>
-      </p:pic>
-      <p:sp>
-        <p:nvSpPr>
-          <p:cNvPr id="6" name="Text 2"/>
-          <p:cNvSpPr/>
-          <p:nvPr/>
-        </p:nvSpPr>
-        <p:spPr>
-          <a:xfrm>
-            <a:off x="457200" y="3977640"/>
-            <a:ext cx="4114800" cy="320040"/>
-          </a:xfrm>
-          <a:prstGeom prst="rect">
-            <a:avLst/>
-          </a:prstGeom>
-          <a:noFill/>
-          <a:ln/>
-        </p:spPr>
-        <p:txBody>
-          <a:bodyPr wrap="square" lIns="0" tIns="0" rIns="0" bIns="0" rtlCol="0" anchor="ctr"/>
-          <a:lstStyle/>
-          <a:p>
-            <a:pPr algn="ctr" indent="0" marL="0">
-              <a:buNone/>
-            </a:pPr>
-            <a:r>
-              <a:rPr lang="en-US" sz="1100" i="1" dirty="0">
-                <a:solidFill>
-                  <a:srgbClr val="64748B"/>
-                </a:solidFill>
-                <a:latin typeface="Calibri" pitchFamily="34" charset="0"/>
-                <a:ea typeface="Calibri" pitchFamily="34" charset="-122"/>
-                <a:cs typeface="Calibri" pitchFamily="34" charset="-120"/>
-              </a:rPr>
-              <a:t>bedrift1 → Bedrift AS (VLAN 10)</a:t>
-            </a:r>
-            <a:endParaRPr lang="en-US" sz="1100" dirty="0"/>
-          </a:p>
-        </p:txBody>
-      </p:sp>
-      <p:sp>
-        <p:nvSpPr>
-          <p:cNvPr id="7" name="Text 3"/>
-          <p:cNvSpPr/>
-          <p:nvPr/>
-        </p:nvSpPr>
-        <p:spPr>
-          <a:xfrm>
-            <a:off x="4754880" y="3977640"/>
-            <a:ext cx="4114800" cy="320040"/>
-          </a:xfrm>
-          <a:prstGeom prst="rect">
-            <a:avLst/>
-          </a:prstGeom>
-          <a:noFill/>
-          <a:ln/>
-        </p:spPr>
-        <p:txBody>
-          <a:bodyPr wrap="square" lIns="0" tIns="0" rIns="0" bIns="0" rtlCol="0" anchor="ctr"/>
-          <a:lstStyle/>
-          <a:p>
-            <a:pPr algn="ctr" indent="0" marL="0">
-              <a:buNone/>
-            </a:pPr>
-            <a:r>
-              <a:rPr lang="en-US" sz="1100" i="1" dirty="0">
-                <a:solidFill>
-                  <a:srgbClr val="64748B"/>
-                </a:solidFill>
-                <a:latin typeface="Calibri" pitchFamily="34" charset="0"/>
-                <a:ea typeface="Calibri" pitchFamily="34" charset="-122"/>
-                <a:cs typeface="Calibri" pitchFamily="34" charset="-120"/>
-              </a:rPr>
-              <a:t>bedrift2 → Konsulent AS (VLAN 20)</a:t>
-            </a:r>
-            <a:endParaRPr lang="en-US" sz="1100" dirty="0"/>
-          </a:p>
-        </p:txBody>
-      </p:sp>
-      <p:sp>
-        <p:nvSpPr>
-          <p:cNvPr id="8" name="Shape 4"/>
-          <p:cNvSpPr/>
-          <p:nvPr/>
-        </p:nvSpPr>
-        <p:spPr>
-          <a:xfrm>
-            <a:off x="457200" y="4370832"/>
-            <a:ext cx="8229600" cy="411480"/>
-          </a:xfrm>
-          <a:prstGeom prst="rect">
-            <a:avLst/>
-          </a:prstGeom>
-          <a:solidFill>
-            <a:srgbClr val="16A34A"/>
-          </a:solidFill>
-          <a:ln w="12700">
-            <a:solidFill>
-              <a:srgbClr val="16A34A"/>
-            </a:solidFill>
-            <a:prstDash val="solid"/>
-          </a:ln>
-        </p:spPr>
-      </p:sp>
-      <p:sp>
-        <p:nvSpPr>
-          <p:cNvPr id="9" name="Text 5"/>
-          <p:cNvSpPr/>
-          <p:nvPr/>
-        </p:nvSpPr>
-        <p:spPr>
-          <a:xfrm>
-            <a:off x="457200" y="4370832"/>
-            <a:ext cx="8229600" cy="411480"/>
-          </a:xfrm>
-          <a:prstGeom prst="rect">
-            <a:avLst/>
-          </a:prstGeom>
-          <a:noFill/>
-          <a:ln/>
-        </p:spPr>
-        <p:txBody>
-          <a:bodyPr wrap="square" lIns="0" tIns="0" rIns="0" bIns="0" rtlCol="0" anchor="ctr"/>
-          <a:lstStyle/>
-          <a:p>
-            <a:pPr algn="ctr" indent="0" marL="0">
-              <a:buNone/>
-            </a:pPr>
-            <a:r>
-              <a:rPr lang="en-US" sz="1300" b="1" dirty="0">
-                <a:solidFill>
-                  <a:srgbClr val="FFFFFF"/>
-                </a:solidFill>
-                <a:latin typeface="Calibri" pitchFamily="34" charset="0"/>
-                <a:ea typeface="Calibri" pitchFamily="34" charset="-122"/>
-                <a:cs typeface="Calibri" pitchFamily="34" charset="-120"/>
-              </a:rPr>
-              <a:t>Hver bedrift ser kun egne data — isolasjon på nett- og applikasjonsnivå ✓</a:t>
-            </a:r>
-            <a:endParaRPr lang="en-US" sz="1300" dirty="0"/>
-          </a:p>
-        </p:txBody>
-      </p:sp>
-    </p:spTree>
-  </p:cSld>
-  <p:clrMapOvr>
-    <a:masterClrMapping/>
-  </p:clrMapOvr>
-</p:sld>
-</file>
-
-<file path=ppt/slides/slide9.xml><?xml version="1.0" encoding="utf-8"?>
-<p:sld xmlns:a="http://schemas.openxmlformats.org/drawingml/2006/main" xmlns:r="http://schemas.openxmlformats.org/officeDocument/2006/relationships" xmlns:p="http://schemas.openxmlformats.org/presentationml/2006/main">
-  <p:cSld name="Slide 9">
-    <p:bg>
-      <p:bgPr>
-        <a:solidFill>
-          <a:srgbClr val="F0F7FF"/>
-        </a:solidFill>
-      </p:bgPr>
-    </p:bg>
-    <p:spTree>
-      <p:nvGrpSpPr>
-        <p:cNvPr id="1" name=""/>
-        <p:cNvGrpSpPr/>
-        <p:nvPr/>
-      </p:nvGrpSpPr>
-      <p:grpSpPr>
-        <a:xfrm>
-          <a:off x="0" y="0"/>
-          <a:ext cx="0" cy="0"/>
-          <a:chOff x="0" y="0"/>
-          <a:chExt cx="0" cy="0"/>
-        </a:xfrm>
-      </p:grpSpPr>
-      <p:sp>
-        <p:nvSpPr>
-          <p:cNvPr id="2" name="Shape 0"/>
-          <p:cNvSpPr/>
-          <p:nvPr/>
-        </p:nvSpPr>
-        <p:spPr>
-          <a:xfrm>
-            <a:off x="0" y="0"/>
-            <a:ext cx="9144000" cy="914400"/>
-          </a:xfrm>
-          <a:prstGeom prst="rect">
-            <a:avLst/>
-          </a:prstGeom>
-          <a:solidFill>
-            <a:srgbClr val="065A82"/>
-          </a:solidFill>
-          <a:ln w="12700">
-            <a:solidFill>
-              <a:srgbClr val="065A82"/>
-            </a:solidFill>
-            <a:prstDash val="solid"/>
-          </a:ln>
-        </p:spPr>
-      </p:sp>
-      <p:sp>
-        <p:nvSpPr>
-          <p:cNvPr id="3" name="Text 1"/>
-          <p:cNvSpPr/>
-          <p:nvPr/>
-        </p:nvSpPr>
-        <p:spPr>
-          <a:xfrm>
-            <a:off x="457200" y="137160"/>
-            <a:ext cx="8229600" cy="640080"/>
-          </a:xfrm>
-          <a:prstGeom prst="rect">
-            <a:avLst/>
-          </a:prstGeom>
-          <a:noFill/>
-          <a:ln/>
-        </p:spPr>
-        <p:txBody>
-          <a:bodyPr wrap="square" lIns="0" tIns="0" rIns="0" bIns="0" rtlCol="0" anchor="ctr"/>
-          <a:lstStyle/>
-          <a:p>
-            <a:pPr indent="0" marL="0">
-              <a:buNone/>
-            </a:pPr>
-            <a:r>
-              <a:rPr lang="en-US" sz="2800" b="1" dirty="0">
-                <a:solidFill>
-                  <a:srgbClr val="FFFFFF"/>
-                </a:solidFill>
-                <a:latin typeface="Calibri" pitchFamily="34" charset="0"/>
-                <a:ea typeface="Calibri" pitchFamily="34" charset="-122"/>
-                <a:cs typeface="Calibri" pitchFamily="34" charset="-120"/>
-              </a:rPr>
               <a:t>Oppgave 1 — Database: MariaDB i Docker</a:t>
             </a:r>
             <a:endParaRPr lang="en-US" sz="2800" dirty="0"/>
@@ -7929,7 +7189,7 @@
       </p:sp>
       <p:graphicFrame>
         <p:nvGraphicFramePr>
-          <p:cNvPr id="10" name="Table 0"/>
+          <p:cNvPr id="7" name="Table 0"/>
           <p:cNvGraphicFramePr>
             <a:graphicFrameLocks noGrp="1"/>
           </p:cNvGraphicFramePr>
@@ -8985,6 +8245,746 @@
 </p:sld>
 </file>
 
+<file path=ppt/slides/slide7.xml><?xml version="1.0" encoding="utf-8"?>
+<p:sld xmlns:a="http://schemas.openxmlformats.org/drawingml/2006/main" xmlns:r="http://schemas.openxmlformats.org/officeDocument/2006/relationships" xmlns:p="http://schemas.openxmlformats.org/presentationml/2006/main">
+  <p:cSld name="Slide 7">
+    <p:bg>
+      <p:bgPr>
+        <a:solidFill>
+          <a:srgbClr val="F0F7FF"/>
+        </a:solidFill>
+      </p:bgPr>
+    </p:bg>
+    <p:spTree>
+      <p:nvGrpSpPr>
+        <p:cNvPr id="1" name=""/>
+        <p:cNvGrpSpPr/>
+        <p:nvPr/>
+      </p:nvGrpSpPr>
+      <p:grpSpPr>
+        <a:xfrm>
+          <a:off x="0" y="0"/>
+          <a:ext cx="0" cy="0"/>
+          <a:chOff x="0" y="0"/>
+          <a:chExt cx="0" cy="0"/>
+        </a:xfrm>
+      </p:grpSpPr>
+      <p:sp>
+        <p:nvSpPr>
+          <p:cNvPr id="2" name="Shape 0"/>
+          <p:cNvSpPr/>
+          <p:nvPr/>
+        </p:nvSpPr>
+        <p:spPr>
+          <a:xfrm>
+            <a:off x="0" y="0"/>
+            <a:ext cx="9144000" cy="914400"/>
+          </a:xfrm>
+          <a:prstGeom prst="rect">
+            <a:avLst/>
+          </a:prstGeom>
+          <a:solidFill>
+            <a:srgbClr val="065A82"/>
+          </a:solidFill>
+          <a:ln w="12700">
+            <a:solidFill>
+              <a:srgbClr val="065A82"/>
+            </a:solidFill>
+            <a:prstDash val="solid"/>
+          </a:ln>
+        </p:spPr>
+      </p:sp>
+      <p:sp>
+        <p:nvSpPr>
+          <p:cNvPr id="3" name="Text 1"/>
+          <p:cNvSpPr/>
+          <p:nvPr/>
+        </p:nvSpPr>
+        <p:spPr>
+          <a:xfrm>
+            <a:off x="457200" y="137160"/>
+            <a:ext cx="8229600" cy="640080"/>
+          </a:xfrm>
+          <a:prstGeom prst="rect">
+            <a:avLst/>
+          </a:prstGeom>
+          <a:noFill/>
+          <a:ln/>
+        </p:spPr>
+        <p:txBody>
+          <a:bodyPr wrap="square" lIns="0" tIns="0" rIns="0" bIns="0" rtlCol="0" anchor="ctr"/>
+          <a:lstStyle/>
+          <a:p>
+            <a:pPr indent="0" marL="0">
+              <a:buNone/>
+            </a:pPr>
+            <a:r>
+              <a:rPr lang="en-US" sz="2800" b="1" dirty="0">
+                <a:solidFill>
+                  <a:srgbClr val="FFFFFF"/>
+                </a:solidFill>
+                <a:latin typeface="Calibri" pitchFamily="34" charset="0"/>
+                <a:ea typeface="Calibri" pitchFamily="34" charset="-122"/>
+                <a:cs typeface="Calibri" pitchFamily="34" charset="-120"/>
+              </a:rPr>
+              <a:t>Oppgave 2 — Drift: Nettverkstopologi</a:t>
+            </a:r>
+            <a:endParaRPr lang="en-US" sz="2800" dirty="0"/>
+          </a:p>
+        </p:txBody>
+      </p:sp>
+      <p:pic>
+        <p:nvPicPr>
+          <p:cNvPr id="4" name="Image 0" descr="C:\Eksamen_2026\bilder\alle_ip_config_ferdig.png">    </p:cNvPr>
+          <p:cNvPicPr>
+            <a:picLocks noChangeAspect="1"/>
+          </p:cNvPicPr>
+          <p:nvPr/>
+        </p:nvPicPr>
+        <p:blipFill>
+          <a:blip r:embed="rId1"/>
+          <a:stretch>
+            <a:fillRect/>
+          </a:stretch>
+        </p:blipFill>
+        <p:spPr>
+          <a:xfrm>
+            <a:off x="457200" y="1005840"/>
+            <a:ext cx="4754880" cy="3474720"/>
+          </a:xfrm>
+          <a:prstGeom prst="rect">
+            <a:avLst/>
+          </a:prstGeom>
+        </p:spPr>
+      </p:pic>
+      <p:sp>
+        <p:nvSpPr>
+          <p:cNvPr id="5" name="Text 2"/>
+          <p:cNvSpPr/>
+          <p:nvPr/>
+        </p:nvSpPr>
+        <p:spPr>
+          <a:xfrm>
+            <a:off x="5394960" y="1188720"/>
+            <a:ext cx="3474720" cy="2286000"/>
+          </a:xfrm>
+          <a:prstGeom prst="rect">
+            <a:avLst/>
+          </a:prstGeom>
+          <a:noFill/>
+          <a:ln/>
+        </p:spPr>
+        <p:txBody>
+          <a:bodyPr wrap="square" rtlCol="0" anchor="ctr"/>
+          <a:lstStyle/>
+          <a:p>
+            <a:pPr marL="342900" indent="-342900">
+              <a:buSzPct val="100000"/>
+              <a:buChar char="•"/>
+            </a:pPr>
+            <a:r>
+              <a:rPr lang="en-US" sz="1300" dirty="0">
+                <a:solidFill>
+                  <a:srgbClr val="1E293B"/>
+                </a:solidFill>
+                <a:latin typeface="Calibri" pitchFamily="34" charset="0"/>
+                <a:ea typeface="Calibri" pitchFamily="34" charset="-122"/>
+                <a:cs typeface="Calibri" pitchFamily="34" charset="-120"/>
+              </a:rPr>
+              <a:t>1 switch (Cisco 2960), 1 router (Cisco 2911)</a:t>
+            </a:r>
+            <a:endParaRPr lang="en-US" sz="1300" dirty="0"/>
+          </a:p>
+          <a:p>
+            <a:pPr marL="342900" indent="-342900">
+              <a:buSzPct val="100000"/>
+              <a:buChar char="•"/>
+            </a:pPr>
+            <a:r>
+              <a:rPr lang="en-US" sz="1300" dirty="0">
+                <a:solidFill>
+                  <a:srgbClr val="1E293B"/>
+                </a:solidFill>
+                <a:latin typeface="Calibri" pitchFamily="34" charset="0"/>
+                <a:ea typeface="Calibri" pitchFamily="34" charset="-122"/>
+                <a:cs typeface="Calibri" pitchFamily="34" charset="-120"/>
+              </a:rPr>
+              <a:t>3 bedrifter × (2 PC + 1 printer)</a:t>
+            </a:r>
+            <a:endParaRPr lang="en-US" sz="1300" dirty="0"/>
+          </a:p>
+          <a:p>
+            <a:pPr marL="342900" indent="-342900">
+              <a:buSzPct val="100000"/>
+              <a:buChar char="•"/>
+            </a:pPr>
+            <a:r>
+              <a:rPr lang="en-US" sz="1300" dirty="0">
+                <a:solidFill>
+                  <a:srgbClr val="1E293B"/>
+                </a:solidFill>
+                <a:latin typeface="Calibri" pitchFamily="34" charset="0"/>
+                <a:ea typeface="Calibri" pitchFamily="34" charset="-122"/>
+                <a:cs typeface="Calibri" pitchFamily="34" charset="-120"/>
+              </a:rPr>
+              <a:t>Server i VLAN 99</a:t>
+            </a:r>
+            <a:endParaRPr lang="en-US" sz="1300" dirty="0"/>
+          </a:p>
+          <a:p>
+            <a:pPr marL="342900" indent="-342900">
+              <a:buSzPct val="100000"/>
+              <a:buChar char="•"/>
+            </a:pPr>
+            <a:r>
+              <a:rPr lang="en-US" sz="1300" dirty="0">
+                <a:solidFill>
+                  <a:srgbClr val="1E293B"/>
+                </a:solidFill>
+                <a:latin typeface="Calibri" pitchFamily="34" charset="0"/>
+                <a:ea typeface="Calibri" pitchFamily="34" charset="-122"/>
+                <a:cs typeface="Calibri" pitchFamily="34" charset="-120"/>
+              </a:rPr>
+              <a:t>Router-on-a-stick med dot1Q</a:t>
+            </a:r>
+            <a:endParaRPr lang="en-US" sz="1300" dirty="0"/>
+          </a:p>
+          <a:p>
+            <a:pPr marL="342900" indent="-342900">
+              <a:buSzPct val="100000"/>
+              <a:buChar char="•"/>
+            </a:pPr>
+            <a:r>
+              <a:rPr lang="en-US" sz="1300" dirty="0">
+                <a:solidFill>
+                  <a:srgbClr val="1E293B"/>
+                </a:solidFill>
+                <a:latin typeface="Calibri" pitchFamily="34" charset="0"/>
+                <a:ea typeface="Calibri" pitchFamily="34" charset="-122"/>
+                <a:cs typeface="Calibri" pitchFamily="34" charset="-120"/>
+              </a:rPr>
+              <a:t>Alle koblinger grønne — oppe</a:t>
+            </a:r>
+            <a:endParaRPr lang="en-US" sz="1300" dirty="0"/>
+          </a:p>
+        </p:txBody>
+      </p:sp>
+      <p:sp>
+        <p:nvSpPr>
+          <p:cNvPr id="6" name="Shape 3"/>
+          <p:cNvSpPr/>
+          <p:nvPr/>
+        </p:nvSpPr>
+        <p:spPr>
+          <a:xfrm>
+            <a:off x="5394960" y="3749040"/>
+            <a:ext cx="3474720" cy="548640"/>
+          </a:xfrm>
+          <a:prstGeom prst="rect">
+            <a:avLst/>
+          </a:prstGeom>
+          <a:solidFill>
+            <a:srgbClr val="16A34A"/>
+          </a:solidFill>
+          <a:ln w="12700">
+            <a:solidFill>
+              <a:srgbClr val="16A34A"/>
+            </a:solidFill>
+            <a:prstDash val="solid"/>
+          </a:ln>
+        </p:spPr>
+      </p:sp>
+      <p:sp>
+        <p:nvSpPr>
+          <p:cNvPr id="7" name="Text 4"/>
+          <p:cNvSpPr/>
+          <p:nvPr/>
+        </p:nvSpPr>
+        <p:spPr>
+          <a:xfrm>
+            <a:off x="5394960" y="3749040"/>
+            <a:ext cx="3474720" cy="548640"/>
+          </a:xfrm>
+          <a:prstGeom prst="rect">
+            <a:avLst/>
+          </a:prstGeom>
+          <a:noFill/>
+          <a:ln/>
+        </p:spPr>
+        <p:txBody>
+          <a:bodyPr wrap="square" lIns="0" tIns="0" rIns="0" bIns="0" rtlCol="0" anchor="ctr"/>
+          <a:lstStyle/>
+          <a:p>
+            <a:pPr algn="ctr" indent="0" marL="0">
+              <a:buNone/>
+            </a:pPr>
+            <a:r>
+              <a:rPr lang="en-US" sz="1500" b="1" dirty="0">
+                <a:solidFill>
+                  <a:srgbClr val="FFFFFF"/>
+                </a:solidFill>
+                <a:latin typeface="Calibri" pitchFamily="34" charset="0"/>
+                <a:ea typeface="Calibri" pitchFamily="34" charset="-122"/>
+                <a:cs typeface="Calibri" pitchFamily="34" charset="-120"/>
+              </a:rPr>
+              <a:t>Oppgave 2 fullført ✓</a:t>
+            </a:r>
+            <a:endParaRPr lang="en-US" sz="1500" dirty="0"/>
+          </a:p>
+        </p:txBody>
+      </p:sp>
+    </p:spTree>
+  </p:cSld>
+  <p:clrMapOvr>
+    <a:masterClrMapping/>
+  </p:clrMapOvr>
+</p:sld>
+</file>
+
+<file path=ppt/slides/slide8.xml><?xml version="1.0" encoding="utf-8"?>
+<p:sld xmlns:a="http://schemas.openxmlformats.org/drawingml/2006/main" xmlns:r="http://schemas.openxmlformats.org/officeDocument/2006/relationships" xmlns:p="http://schemas.openxmlformats.org/presentationml/2006/main">
+  <p:cSld name="Slide 8">
+    <p:bg>
+      <p:bgPr>
+        <a:solidFill>
+          <a:srgbClr val="F0F7FF"/>
+        </a:solidFill>
+      </p:bgPr>
+    </p:bg>
+    <p:spTree>
+      <p:nvGrpSpPr>
+        <p:cNvPr id="1" name=""/>
+        <p:cNvGrpSpPr/>
+        <p:nvPr/>
+      </p:nvGrpSpPr>
+      <p:grpSpPr>
+        <a:xfrm>
+          <a:off x="0" y="0"/>
+          <a:ext cx="0" cy="0"/>
+          <a:chOff x="0" y="0"/>
+          <a:chExt cx="0" cy="0"/>
+        </a:xfrm>
+      </p:grpSpPr>
+      <p:sp>
+        <p:nvSpPr>
+          <p:cNvPr id="2" name="Shape 0"/>
+          <p:cNvSpPr/>
+          <p:nvPr/>
+        </p:nvSpPr>
+        <p:spPr>
+          <a:xfrm>
+            <a:off x="0" y="0"/>
+            <a:ext cx="9144000" cy="914400"/>
+          </a:xfrm>
+          <a:prstGeom prst="rect">
+            <a:avLst/>
+          </a:prstGeom>
+          <a:solidFill>
+            <a:srgbClr val="065A82"/>
+          </a:solidFill>
+          <a:ln w="12700">
+            <a:solidFill>
+              <a:srgbClr val="065A82"/>
+            </a:solidFill>
+            <a:prstDash val="solid"/>
+          </a:ln>
+        </p:spPr>
+      </p:sp>
+      <p:sp>
+        <p:nvSpPr>
+          <p:cNvPr id="3" name="Text 1"/>
+          <p:cNvSpPr/>
+          <p:nvPr/>
+        </p:nvSpPr>
+        <p:spPr>
+          <a:xfrm>
+            <a:off x="457200" y="137160"/>
+            <a:ext cx="8229600" cy="640080"/>
+          </a:xfrm>
+          <a:prstGeom prst="rect">
+            <a:avLst/>
+          </a:prstGeom>
+          <a:noFill/>
+          <a:ln/>
+        </p:spPr>
+        <p:txBody>
+          <a:bodyPr wrap="square" lIns="0" tIns="0" rIns="0" bIns="0" rtlCol="0" anchor="ctr"/>
+          <a:lstStyle/>
+          <a:p>
+            <a:pPr indent="0" marL="0">
+              <a:buNone/>
+            </a:pPr>
+            <a:r>
+              <a:rPr lang="en-US" sz="2800" b="1" dirty="0">
+                <a:solidFill>
+                  <a:srgbClr val="FFFFFF"/>
+                </a:solidFill>
+                <a:latin typeface="Calibri" pitchFamily="34" charset="0"/>
+                <a:ea typeface="Calibri" pitchFamily="34" charset="-122"/>
+                <a:cs typeface="Calibri" pitchFamily="34" charset="-120"/>
+              </a:rPr>
+              <a:t>Drift — VLAN og router-konfigurasjon</a:t>
+            </a:r>
+            <a:endParaRPr lang="en-US" sz="2800" dirty="0"/>
+          </a:p>
+        </p:txBody>
+      </p:sp>
+      <p:pic>
+        <p:nvPicPr>
+          <p:cNvPr id="4" name="Image 0" descr="C:\Eksamen_2026\bilder\show_vlan_brief.png">    </p:cNvPr>
+          <p:cNvPicPr>
+            <a:picLocks noChangeAspect="1"/>
+          </p:cNvPicPr>
+          <p:nvPr/>
+        </p:nvPicPr>
+        <p:blipFill>
+          <a:blip r:embed="rId1"/>
+          <a:stretch>
+            <a:fillRect/>
+          </a:stretch>
+        </p:blipFill>
+        <p:spPr>
+          <a:xfrm>
+            <a:off x="457200" y="1005840"/>
+            <a:ext cx="4114800" cy="3017520"/>
+          </a:xfrm>
+          <a:prstGeom prst="rect">
+            <a:avLst/>
+          </a:prstGeom>
+        </p:spPr>
+      </p:pic>
+      <p:pic>
+        <p:nvPicPr>
+          <p:cNvPr id="5" name="Image 1" descr="C:\Eksamen_2026\bilder\running_config.png">    </p:cNvPr>
+          <p:cNvPicPr>
+            <a:picLocks noChangeAspect="1"/>
+          </p:cNvPicPr>
+          <p:nvPr/>
+        </p:nvPicPr>
+        <p:blipFill>
+          <a:blip r:embed="rId2"/>
+          <a:stretch>
+            <a:fillRect/>
+          </a:stretch>
+        </p:blipFill>
+        <p:spPr>
+          <a:xfrm>
+            <a:off x="4754880" y="1005840"/>
+            <a:ext cx="4114800" cy="3017520"/>
+          </a:xfrm>
+          <a:prstGeom prst="rect">
+            <a:avLst/>
+          </a:prstGeom>
+        </p:spPr>
+      </p:pic>
+      <p:sp>
+        <p:nvSpPr>
+          <p:cNvPr id="6" name="Text 2"/>
+          <p:cNvSpPr/>
+          <p:nvPr/>
+        </p:nvSpPr>
+        <p:spPr>
+          <a:xfrm>
+            <a:off x="457200" y="4114800"/>
+            <a:ext cx="4114800" cy="365760"/>
+          </a:xfrm>
+          <a:prstGeom prst="rect">
+            <a:avLst/>
+          </a:prstGeom>
+          <a:noFill/>
+          <a:ln/>
+        </p:spPr>
+        <p:txBody>
+          <a:bodyPr wrap="square" lIns="0" tIns="0" rIns="0" bIns="0" rtlCol="0" anchor="ctr"/>
+          <a:lstStyle/>
+          <a:p>
+            <a:pPr algn="ctr" indent="0" marL="0">
+              <a:buNone/>
+            </a:pPr>
+            <a:r>
+              <a:rPr lang="en-US" sz="1100" i="1" dirty="0">
+                <a:solidFill>
+                  <a:srgbClr val="64748B"/>
+                </a:solidFill>
+                <a:latin typeface="Calibri" pitchFamily="34" charset="0"/>
+                <a:ea typeface="Calibri" pitchFamily="34" charset="-122"/>
+                <a:cs typeface="Calibri" pitchFamily="34" charset="-120"/>
+              </a:rPr>
+              <a:t>show vlan brief — Switch0</a:t>
+            </a:r>
+            <a:endParaRPr lang="en-US" sz="1100" dirty="0"/>
+          </a:p>
+        </p:txBody>
+      </p:sp>
+      <p:sp>
+        <p:nvSpPr>
+          <p:cNvPr id="7" name="Text 3"/>
+          <p:cNvSpPr/>
+          <p:nvPr/>
+        </p:nvSpPr>
+        <p:spPr>
+          <a:xfrm>
+            <a:off x="4754880" y="4114800"/>
+            <a:ext cx="4114800" cy="365760"/>
+          </a:xfrm>
+          <a:prstGeom prst="rect">
+            <a:avLst/>
+          </a:prstGeom>
+          <a:noFill/>
+          <a:ln/>
+        </p:spPr>
+        <p:txBody>
+          <a:bodyPr wrap="square" lIns="0" tIns="0" rIns="0" bIns="0" rtlCol="0" anchor="ctr"/>
+          <a:lstStyle/>
+          <a:p>
+            <a:pPr algn="ctr" indent="0" marL="0">
+              <a:buNone/>
+            </a:pPr>
+            <a:r>
+              <a:rPr lang="en-US" sz="1100" i="1" dirty="0">
+                <a:solidFill>
+                  <a:srgbClr val="64748B"/>
+                </a:solidFill>
+                <a:latin typeface="Calibri" pitchFamily="34" charset="0"/>
+                <a:ea typeface="Calibri" pitchFamily="34" charset="-122"/>
+                <a:cs typeface="Calibri" pitchFamily="34" charset="-120"/>
+              </a:rPr>
+              <a:t>show running-config — Router0</a:t>
+            </a:r>
+            <a:endParaRPr lang="en-US" sz="1100" dirty="0"/>
+          </a:p>
+        </p:txBody>
+      </p:sp>
+    </p:spTree>
+  </p:cSld>
+  <p:clrMapOvr>
+    <a:masterClrMapping/>
+  </p:clrMapOvr>
+</p:sld>
+</file>
+
+<file path=ppt/slides/slide9.xml><?xml version="1.0" encoding="utf-8"?>
+<p:sld xmlns:a="http://schemas.openxmlformats.org/drawingml/2006/main" xmlns:r="http://schemas.openxmlformats.org/officeDocument/2006/relationships" xmlns:p="http://schemas.openxmlformats.org/presentationml/2006/main">
+  <p:cSld name="Slide 9">
+    <p:bg>
+      <p:bgPr>
+        <a:solidFill>
+          <a:srgbClr val="F0F7FF"/>
+        </a:solidFill>
+      </p:bgPr>
+    </p:bg>
+    <p:spTree>
+      <p:nvGrpSpPr>
+        <p:cNvPr id="1" name=""/>
+        <p:cNvGrpSpPr/>
+        <p:nvPr/>
+      </p:nvGrpSpPr>
+      <p:grpSpPr>
+        <a:xfrm>
+          <a:off x="0" y="0"/>
+          <a:ext cx="0" cy="0"/>
+          <a:chOff x="0" y="0"/>
+          <a:chExt cx="0" cy="0"/>
+        </a:xfrm>
+      </p:grpSpPr>
+      <p:sp>
+        <p:nvSpPr>
+          <p:cNvPr id="2" name="Shape 0"/>
+          <p:cNvSpPr/>
+          <p:nvPr/>
+        </p:nvSpPr>
+        <p:spPr>
+          <a:xfrm>
+            <a:off x="0" y="0"/>
+            <a:ext cx="9144000" cy="914400"/>
+          </a:xfrm>
+          <a:prstGeom prst="rect">
+            <a:avLst/>
+          </a:prstGeom>
+          <a:solidFill>
+            <a:srgbClr val="065A82"/>
+          </a:solidFill>
+          <a:ln w="12700">
+            <a:solidFill>
+              <a:srgbClr val="065A82"/>
+            </a:solidFill>
+            <a:prstDash val="solid"/>
+          </a:ln>
+        </p:spPr>
+      </p:sp>
+      <p:sp>
+        <p:nvSpPr>
+          <p:cNvPr id="3" name="Text 1"/>
+          <p:cNvSpPr/>
+          <p:nvPr/>
+        </p:nvSpPr>
+        <p:spPr>
+          <a:xfrm>
+            <a:off x="457200" y="137160"/>
+            <a:ext cx="8229600" cy="640080"/>
+          </a:xfrm>
+          <a:prstGeom prst="rect">
+            <a:avLst/>
+          </a:prstGeom>
+          <a:noFill/>
+          <a:ln/>
+        </p:spPr>
+        <p:txBody>
+          <a:bodyPr wrap="square" lIns="0" tIns="0" rIns="0" bIns="0" rtlCol="0" anchor="ctr"/>
+          <a:lstStyle/>
+          <a:p>
+            <a:pPr indent="0" marL="0">
+              <a:buNone/>
+            </a:pPr>
+            <a:r>
+              <a:rPr lang="en-US" sz="2800" b="1" dirty="0">
+                <a:solidFill>
+                  <a:srgbClr val="FFFFFF"/>
+                </a:solidFill>
+                <a:latin typeface="Calibri" pitchFamily="34" charset="0"/>
+                <a:ea typeface="Calibri" pitchFamily="34" charset="-122"/>
+                <a:cs typeface="Calibri" pitchFamily="34" charset="-120"/>
+              </a:rPr>
+              <a:t>Drift — Isolasjon og IP-konfigurasjon bekreftet</a:t>
+            </a:r>
+            <a:endParaRPr lang="en-US" sz="2800" dirty="0"/>
+          </a:p>
+        </p:txBody>
+      </p:sp>
+      <p:pic>
+        <p:nvPicPr>
+          <p:cNvPr id="4" name="Image 0" descr="C:\Eksamen_2026\bilder\ping_test.png">    </p:cNvPr>
+          <p:cNvPicPr>
+            <a:picLocks noChangeAspect="1"/>
+          </p:cNvPicPr>
+          <p:nvPr/>
+        </p:nvPicPr>
+        <p:blipFill>
+          <a:blip r:embed="rId1"/>
+          <a:stretch>
+            <a:fillRect/>
+          </a:stretch>
+        </p:blipFill>
+        <p:spPr>
+          <a:xfrm>
+            <a:off x="457200" y="1005840"/>
+            <a:ext cx="4114800" cy="3017520"/>
+          </a:xfrm>
+          <a:prstGeom prst="rect">
+            <a:avLst/>
+          </a:prstGeom>
+        </p:spPr>
+      </p:pic>
+      <p:pic>
+        <p:nvPicPr>
+          <p:cNvPr id="5" name="Image 1" descr="C:\Eksamen_2026\bilder\ip_config.png">    </p:cNvPr>
+          <p:cNvPicPr>
+            <a:picLocks noChangeAspect="1"/>
+          </p:cNvPicPr>
+          <p:nvPr/>
+        </p:nvPicPr>
+        <p:blipFill>
+          <a:blip r:embed="rId2"/>
+          <a:stretch>
+            <a:fillRect/>
+          </a:stretch>
+        </p:blipFill>
+        <p:spPr>
+          <a:xfrm>
+            <a:off x="4754880" y="1005840"/>
+            <a:ext cx="4114800" cy="3017520"/>
+          </a:xfrm>
+          <a:prstGeom prst="rect">
+            <a:avLst/>
+          </a:prstGeom>
+        </p:spPr>
+      </p:pic>
+      <p:sp>
+        <p:nvSpPr>
+          <p:cNvPr id="6" name="Text 2"/>
+          <p:cNvSpPr/>
+          <p:nvPr/>
+        </p:nvSpPr>
+        <p:spPr>
+          <a:xfrm>
+            <a:off x="457200" y="4114800"/>
+            <a:ext cx="4114800" cy="365760"/>
+          </a:xfrm>
+          <a:prstGeom prst="rect">
+            <a:avLst/>
+          </a:prstGeom>
+          <a:noFill/>
+          <a:ln/>
+        </p:spPr>
+        <p:txBody>
+          <a:bodyPr wrap="square" lIns="0" tIns="0" rIns="0" bIns="0" rtlCol="0" anchor="ctr"/>
+          <a:lstStyle/>
+          <a:p>
+            <a:pPr algn="ctr" indent="0" marL="0">
+              <a:buNone/>
+            </a:pPr>
+            <a:r>
+              <a:rPr lang="en-US" sz="1100" i="1" dirty="0">
+                <a:solidFill>
+                  <a:srgbClr val="64748B"/>
+                </a:solidFill>
+                <a:latin typeface="Calibri" pitchFamily="34" charset="0"/>
+                <a:ea typeface="Calibri" pitchFamily="34" charset="-122"/>
+                <a:cs typeface="Calibri" pitchFamily="34" charset="-120"/>
+              </a:rPr>
+              <a:t>Ping-test: intra-VLAN Reply ✓ / inter-VLAN Timed out ✓</a:t>
+            </a:r>
+            <a:endParaRPr lang="en-US" sz="1100" dirty="0"/>
+          </a:p>
+        </p:txBody>
+      </p:sp>
+      <p:sp>
+        <p:nvSpPr>
+          <p:cNvPr id="7" name="Text 3"/>
+          <p:cNvSpPr/>
+          <p:nvPr/>
+        </p:nvSpPr>
+        <p:spPr>
+          <a:xfrm>
+            <a:off x="4754880" y="4114800"/>
+            <a:ext cx="4114800" cy="365760"/>
+          </a:xfrm>
+          <a:prstGeom prst="rect">
+            <a:avLst/>
+          </a:prstGeom>
+          <a:noFill/>
+          <a:ln/>
+        </p:spPr>
+        <p:txBody>
+          <a:bodyPr wrap="square" lIns="0" tIns="0" rIns="0" bIns="0" rtlCol="0" anchor="ctr"/>
+          <a:lstStyle/>
+          <a:p>
+            <a:pPr algn="ctr" indent="0" marL="0">
+              <a:buNone/>
+            </a:pPr>
+            <a:r>
+              <a:rPr lang="en-US" sz="1100" i="1" dirty="0">
+                <a:solidFill>
+                  <a:srgbClr val="64748B"/>
+                </a:solidFill>
+                <a:latin typeface="Calibri" pitchFamily="34" charset="0"/>
+                <a:ea typeface="Calibri" pitchFamily="34" charset="-122"/>
+                <a:cs typeface="Calibri" pitchFamily="34" charset="-120"/>
+              </a:rPr>
+              <a:t>IP-konfig PC0 — 192.168.10.2 / gateway 192.168.10.1</a:t>
+            </a:r>
+            <a:endParaRPr lang="en-US" sz="1100" dirty="0"/>
+          </a:p>
+        </p:txBody>
+      </p:sp>
+    </p:spTree>
+  </p:cSld>
+  <p:clrMapOvr>
+    <a:masterClrMapping/>
+  </p:clrMapOvr>
+</p:sld>
+</file>
+
 <file path=ppt/theme/theme1.xml><?xml version="1.0" encoding="utf-8"?>
 <a:theme xmlns:a="http://schemas.openxmlformats.org/drawingml/2006/main" name="Office Theme">
   <a:themeElements>

</xml_diff>